<commit_message>
Rename the tap to the queue in the architecture deck
The deck follows the code: the queue, QueuePublisher, QueueRelay and
QUEUE_STALLED, with the glossary row moved to stay alphabetical. The log
drawn as a tape keeps its name. Where the deck used "queue" for replay
requests waiting on a slot, it now says they wait or are pending, as the
code does, and the three "Queue · aeron:ipc 205" labels are widened to stay
on one line.
</commit_message>
<xml_diff>
--- a/doc/presentation/seqeron-architecture.pptx
+++ b/doc/presentation/seqeron-architecture.pptx
@@ -162,7 +162,7 @@
   <p:extLst>
     <p:ext uri="{521415D9-36F7-43E2-AB2F-B90AF26B5E84}">
       <p14:sectionLst xmlns:p14="http://schemas.microsoft.com/office/powerpoint/2010/main">
-        <p14:section name="Opening" id="{C3E02AEA-F0C7-420E-A8C3-D5E923A7ED58}">
+        <p14:section name="Opening" id="{3E9E6C67-88EB-4A70-9695-500350344A6B}">
           <p14:sldIdLst>
             <p14:sldId id="256"/>
             <p14:sldId id="257"/>
@@ -170,14 +170,14 @@
             <p14:sldId id="259"/>
           </p14:sldIdLst>
         </p14:section>
-        <p14:section name="Aeron and Aeron Cluster" id="{FA469B39-2CE4-4739-BE1E-29C45859B0ED}">
+        <p14:section name="Aeron and Aeron Cluster" id="{CC9E2E8E-A891-4480-98A7-BF7211D57E2A}">
           <p14:sldIdLst>
             <p14:sldId id="260"/>
             <p14:sldId id="261"/>
             <p14:sldId id="262"/>
           </p14:sldIdLst>
         </p14:section>
-        <p14:section name="seqeron overview" id="{AEED9346-C1CE-447A-AF0D-5A182C2A1131}">
+        <p14:section name="seqeron overview" id="{7A79A375-ACBC-4533-B8CA-84016A1E7CD8}">
           <p14:sldIdLst>
             <p14:sldId id="263"/>
             <p14:sldId id="264"/>
@@ -187,7 +187,7 @@
             <p14:sldId id="268"/>
           </p14:sldIdLst>
         </p14:section>
-        <p14:section name="Gateways and applications" id="{2D3F9645-12C6-437B-87DA-6FFEC83E67F8}">
+        <p14:section name="Gateways and applications" id="{017FF6B3-4D26-4B12-8075-32301AABB82F}">
           <p14:sldIdLst>
             <p14:sldId id="269"/>
             <p14:sldId id="270"/>
@@ -197,20 +197,20 @@
             <p14:sldId id="274"/>
           </p14:sldIdLst>
         </p14:section>
-        <p14:section name="Failures and verification" id="{3CA7FE10-B757-4E64-BE10-194E1DE98DE2}">
+        <p14:section name="Failures and verification" id="{CA891CD1-8562-4E22-8D04-F4711E041906}">
           <p14:sldIdLst>
             <p14:sldId id="275"/>
             <p14:sldId id="276"/>
             <p14:sldId id="277"/>
           </p14:sldIdLst>
         </p14:section>
-        <p14:section name="Building on Aeron" id="{05C32B70-8C91-4062-A2E2-74E94D7F06EA}">
+        <p14:section name="Building on Aeron" id="{0445D37B-8BDB-452C-8B74-19A63EFB1AAD}">
           <p14:sldIdLst>
             <p14:sldId id="278"/>
             <p14:sldId id="279"/>
           </p14:sldIdLst>
         </p14:section>
-        <p14:section name="Appendix" id="{99D47306-4C49-43C3-844B-2626B5DACB91}">
+        <p14:section name="Appendix" id="{6D15A7B2-2E36-4D23-9AD5-A51A63356363}">
           <p14:sldIdLst>
             <p14:sldId id="280"/>
             <p14:sldId id="281"/>
@@ -714,7 +714,7 @@
           <a:lstStyle/>
           <a:p>
             <a:r>
-              <a:t>All members apply the same committed log in the same order with the same state, so their taps are byte-identical frame for frame. Each archive therefore holds complete history: no cross-node replication of recordings and no leader-only archive. The tap is created once at start and never re-created on a leadership change, so a recording is one continuous run across every leader tenure. The offer is reliable because a dropped frame is a permanent hole, and bounded because only the archive, the one tethered subscriber, can hold it back. A slow archive that still advances is never timed out. One that makes no progress for 200 ms raises the stall gauge, and after 1 s the member exits with code 70 rather than throw: a throwing cluster callback has already had its log position advanced.</a:t>
+              <a:t>All members apply the same committed log in the same order with the same state, so their queues are byte-identical frame for frame. Each archive therefore holds complete history: no cross-node replication of recordings and no leader-only archive. The queue is created once at start and never re-created on a leadership change, so a recording is one continuous run across every leader tenure. The offer is reliable because a dropped frame is a permanent hole, and bounded because only the archive, the one tethered subscriber, can hold it back. A slow archive that still advances is never timed out. One that makes no progress for 200 ms raises the stall gauge, and after 1 s the member exits with code 70 rather than throw: a throwing cluster callback has already had its log position advanced.</a:t>
             </a:r>
           </a:p>
         </p:txBody>
@@ -784,7 +784,7 @@
           <a:lstStyle/>
           <a:p>
             <a:r>
-              <a:t>Consumers read the tap directly and untethered: one that falls a window behind is dropped by its driver within about 0.2 s and heals by replay. History for a cold start or a gap is served by the co-located ReplayerService; nothing reads the archive except through it. It serves only the active recording, which holds the whole log because every member start replays from globalSeqNo 1. The Replayer checks nothing itself: each client checks that its first frame is globalSeqNo 1 and that a resume opens on the frame it asked for, and stops otherwise. Four replays at once; a slot frees when its replay's publication leaves the driver, at once when the client closes its replay subscription, within the driver's 10 s liveness timeout when the client died, below the client's 60 s recovery-stall fence. While the tap's recording trails the tap by more than a quarter of the publication window, a new replay starts only when none is running: replays compete with the recorder for the disk, and the recorder is what holds the sequencer back. seqeron_replayer_throttled_requests_total counts the requests held for that reason, and a member warns at start on Linux when its Aeron directory is not on tmpfs. Control replies are retried briefly and dropped, never blocked on.</a:t>
+              <a:t>Consumers read the queue directly and untethered: one that falls a window behind is dropped by its driver within about 0.2 s and heals by replay. History for a cold start or a gap is served by the co-located ReplayerService; nothing reads the archive except through it. It serves only the active recording, which holds the whole log because every member start replays from globalSeqNo 1. The Replayer checks nothing itself: each client checks that its first frame is globalSeqNo 1 and that a resume opens on the frame it asked for, and stops otherwise. Four replays at once; a slot frees when its replay's publication leaves the driver, at once when the client closes its replay subscription, within the driver's 10 s liveness timeout when the client died, below the client's 60 s recovery-stall fence. While the queue's recording trails the queue by more than a quarter of the publication window, a new replay starts only when none is running: replays compete with the recorder for the disk, and the recorder is what holds the sequencer back. seqeron_replayer_throttled_requests_total counts the requests held for that reason, and a member warns at start on Linux when its Aeron directory is not on tmpfs. Control replies are retried briefly and dropped, never blocked on.</a:t>
             </a:r>
           </a:p>
         </p:txBody>
@@ -854,7 +854,7 @@
           <a:lstStyle/>
           <a:p>
             <a:r>
-              <a:t>Schema 210, two families. The application family carries an opaque payload named by payloadId: Unsequenced on ingress, Sequenced on the tap. The system family is seqeron's own vocabulary, named by systemEventType at the same offset 16. Every field is at the same offset in all eight templates, so a consumer tracks continuity without branching on message type. sessionId is overwritten by the sequencer with the session the frame arrived on; the other ingress fields are copied. Consumers split by family first, then dispatch on (payloadId, templateId), never templateId alone. On the wire the 8-byte SBE message header comes first and the payload's 2-byte length prefix after the header, so a frame carries 8 + 18 + 2 = 28 bytes besides its payload on ingress, and 8 + 34 + 2 = 44 on the tap.</a:t>
+              <a:t>Schema 210, two families. The application family carries an opaque payload named by payloadId: Unsequenced on ingress, Sequenced on the queue. The system family is seqeron's own vocabulary, named by systemEventType at the same offset 16. Every field is at the same offset in all eight templates, so a consumer tracks continuity without branching on message type. sessionId is overwritten by the sequencer with the session the frame arrived on; the other ingress fields are copied. Consumers split by family first, then dispatch on (payloadId, templateId), never templateId alone. On the wire the 8-byte SBE message header comes first and the payload's 2-byte length prefix after the header, so a frame carries 8 + 18 + 2 = 28 bytes besides its payload on ingress, and 8 + 34 + 2 = 44 on the queue.</a:t>
             </a:r>
           </a:p>
         </p:txBody>
@@ -1064,7 +1064,7 @@
           <a:lstStyle/>
           <a:p>
             <a:r>
-              <a:t>Both are from getting-started.md, trimmed to seqeron's part: connecting to the media driver is one Aeron call before them, and the idle strategy is Agrona's. The consumer is one object, ReplayerStreamReceiver, and one poll per duty cycle: it asks its member's Replayer for the history, delivers it, and switches to the live tap when the two meet, every frame once and in globalSeqNo order. The producer takes a façade, here Application: it holds the cluster session, follows the stream, confirms its own messages and resends what a failover lost, and opens its gate only on the leader's member, so the loop is the application's own logic. Published means placed: the message is sequenced when it comes back through onSequenced. onFenced means stop: the façade has already closed the gate and released the session, and the examples exit with 70, the repository's convention for fenced, restart me. Nothing here starts a thread: doWork() and poll() return a work count for the caller's idle strategy. C++ and C# have the same façades; C# takes an options class where Java takes a builder.</a:t>
+              <a:t>Both are from getting-started.md, trimmed to seqeron's part: connecting to the media driver is one Aeron call before them, and the idle strategy is Agrona's. The consumer is one object, ReplayerStreamReceiver, and one poll per duty cycle: it asks its member's Replayer for the history, delivers it, and switches to the live queue when the two meet, every frame once and in globalSeqNo order. The producer takes a façade, here Application: it holds the cluster session, follows the stream, confirms its own messages and resends what a failover lost, and opens its gate only on the leader's member, so the loop is the application's own logic. Published means placed: the message is sequenced when it comes back through onSequenced. onFenced means stop: the façade has already closed the gate and released the session, and the examples exit with 70, the repository's convention for fenced, restart me. Nothing here starts a thread: doWork() and poll() return a work count for the caller's idle strategy. C++ and C# have the same façades; C# takes an options class where Java takes a builder.</a:t>
             </a:r>
           </a:p>
         </p:txBody>
@@ -1274,7 +1274,7 @@
           <a:lstStyle/>
           <a:p>
             <a:r>
-              <a:t>A send returns once the frame is on the leader's ingress publication; the cluster confirms nothing. Frames the old leader had not committed are lost, and the session survives, so neither side sees a fault: about 5,500 frames at 100 µs pacing in the failover harness. PendingSends holds each placed frame until the producer's own tap shows it, matched by cluster session. A LeadershipChanged with a newer term identifies exactly which were lost: the newest frames stamped with the old term that have not appeared. Nothing new is placed until they are resent, oldest first. Each frame is then sequenced exactly once, in order. The limit: this is in memory, so a restarted producer or a promoted standby starts with nothing pending, and a replaced session or a superseded gateway instance drops what was pending.</a:t>
+              <a:t>A send returns once the frame is on the leader's ingress publication; the cluster confirms nothing. Frames the old leader had not committed are lost, and the session survives, so neither side sees a fault: about 5,500 frames at 100 µs pacing in the failover harness. PendingSends holds each placed frame until the producer's own queue shows it, matched by cluster session. A LeadershipChanged with a newer term identifies exactly which were lost: the newest frames stamped with the old term that have not appeared. Nothing new is placed until they are resent, oldest first. Each frame is then sequenced exactly once, in order. The limit: this is in memory, so a restarted producer or a promoted standby starts with nothing pending, and a replaced session or a superseded gateway instance drops what was pending.</a:t>
             </a:r>
           </a:p>
         </p:txBody>
@@ -1484,7 +1484,7 @@
           <a:lstStyle/>
           <a:p>
             <a:r>
-              <a:t>Walk the table top to bottom. Note what is absent: there is no recovery procedure that is not a replay. globalSeqNo, the gateway list and the active instance are all functions of the log. The timings are the defaults. A follower starts an election after 200 ms without a leader heartbeat; how long the election takes is not measured. A member exits after 1 s of back-pressure with no recording progress, and a stopped recording is caught by the 1 Hz heartbeat's liveness check. A slow consumer's driver drops it within about 0.2 s. A missed frame shows at the next frame, which the heartbeat bounds at about a second. The cluster closes a silent client's session after the 1 s session timeout, which is what promotes a crashed gateway's standby. A fence on a mismatch is immediate; the stall fences wait 20 s on the tap and 60 s in recovery, and only on an instance that acts. A fenced gateway's standby takes over at once, but nothing replaces a fenced leader's application replica: that application's leader-only work waits until the replica restarts and catches up, or leadership moves. A gateway host's relay moves after 3 s, three heartbeats, with no frame.</a:t>
+              <a:t>Walk the table top to bottom. Note what is absent: there is no recovery procedure that is not a replay. globalSeqNo, the gateway list and the active instance are all functions of the log. The timings are the defaults. A follower starts an election after 200 ms without a leader heartbeat; how long the election takes is not measured. A member exits after 1 s of back-pressure with no recording progress, and a stopped recording is caught by the 1 Hz heartbeat's liveness check. A slow consumer's driver drops it within about 0.2 s. A missed frame shows at the next frame, which the heartbeat bounds at about a second. The cluster closes a silent client's session after the 1 s session timeout, which is what promotes a crashed gateway's standby. A fence on a mismatch is immediate; the stall fences wait 20 s on the queue and 60 s in recovery, and only on an instance that acts. A fenced gateway's standby takes over at once, but nothing replaces a fenced leader's application replica: that application's leader-only work waits until the replica restarts and catches up, or leadership moves. A gateway host's relay moves after 3 s, three heartbeats, with no frame.</a:t>
             </a:r>
           </a:p>
         </p:txBody>
@@ -1624,7 +1624,7 @@
           <a:lstStyle/>
           <a:p>
             <a:r>
-              <a:t>One exporter runs beside each member, sharing its Aeron directory, and serves the member's counters over HTTP in Prometheus text format, read live from the CnC file; it needs no cluster session. Prometheus pulls every exporter from a static target list, and its own up metric is the member's reachability. Grafana is provisioned from files with one dashboard: a panel per metric family plus node apply lag, now minus the last ClusterHeartbeat, which is the one place a member publishing a contiguous but stale tap shows up. Clients publish counters too: recovery stalled, a gateway instance's open connections, an instance's confirmed snapshot round, and an application's own in type ids 5201 to 5297, labelled by member and client. Not provided: alert rules, service discovery, authentication on the metrics endpoint.</a:t>
+              <a:t>One exporter runs beside each member, sharing its Aeron directory, and serves the member's counters over HTTP in Prometheus text format, read live from the CnC file; it needs no cluster session. Prometheus pulls every exporter from a static target list, and its own up metric is the member's reachability. Grafana is provisioned from files with one dashboard: a panel per metric family plus node apply lag, now minus the last ClusterHeartbeat, which is the one place a member publishing a contiguous but stale queue shows up. Clients publish counters too: recovery stalled, a gateway instance's open connections, an instance's confirmed snapshot round, and an application's own in type ids 5201 to 5297, labelled by member and client. Not provided: alert rules, service discovery, authentication on the metrics endpoint.</a:t>
             </a:r>
           </a:p>
         </p:txBody>
@@ -1694,7 +1694,7 @@
           <a:lstStyle/>
           <a:p>
             <a:r>
-              <a:t>Each row is a behavior of Aeron that is correct by its own contract and easy to build on wrongly, and each is already on a slide. Confirmed ingress answers the first; the tap's bounded, reliable offer the fourth and fifth; the replay sequences the seventh. A cluster callback that throws has had its log position advanced by Image.boundedControlledPoll and AgentRunner keeps the agent alive, so the frame is dropped and nothing stops; a member that cannot continue exits with code 70 instead. The client side is the same: Image.poll gives a handler's exception to the error handler and advances, so a client records the fault and raises it from its own duty cycle. CLOSED from an ingress offer is an election in progress, not a dead session. Aeron.NET's defaults are Aeron's, whose new-leader timeout is shorter than an election, which csharp-client-test.sh catches on every pull request.</a:t>
+              <a:t>Each row is a behavior of Aeron that is correct by its own contract and easy to build on wrongly, and each is already on a slide. Confirmed ingress answers the first; the queue's bounded, reliable offer the fourth and fifth; the replay sequences the seventh. A cluster callback that throws has had its log position advanced by Image.boundedControlledPoll and AgentRunner keeps the agent alive, so the frame is dropped and nothing stops; a member that cannot continue exits with code 70 instead. The client side is the same: Image.poll gives a handler's exception to the error handler and advances, so a client records the fault and raises it from its own duty cycle. CLOSED from an ingress offer is an election in progress, not a dead session. Aeron.NET's defaults are Aeron's, whose new-leader timeout is shorter than an election, which csharp-client-test.sh catches on every pull request.</a:t>
             </a:r>
           </a:p>
         </p:txBody>
@@ -1834,7 +1834,7 @@
           <a:lstStyle/>
           <a:p>
             <a:r>
-              <a:t>The cluster tier's own failover, the Raft election and a member that exits rather than lose its recording, is on the failure model slide. These are the client tier's. Ingress: a co-located producer uses IPC to its own member and UDP to the leader otherwise; Java and C# replace the session when leadership moves off the co-located member, C++ swaps only its publication and follows a follower's redirect. A send spins through an election rather than dropping the frame. A session the cluster closed is replaced, one attempt a second, and the instance fences after 20 s without one; a gateway instance that announced itself on the lost session fences at once, since its sibling may already be designated. PendingSends resends what the old leader lost, exactly once and in order. The gateway pair and the leader-only work of applications move with the log. A gateway host's relay moves to the next member's archive and resumes at the same position, valid because every member's active recording starts at globalSeqNo 1. A client's own Replayer, tap and media driver have no alternative: an instance that acts fences. A fenced gateway instance's standby takes over at once; nothing replaces a fenced leader's application replica, so that application's leader-only work waits until the replica restarts and catches up, or leadership moves to another member.</a:t>
+              <a:t>The cluster tier's own failover, the Raft election and a member that exits rather than lose its recording, is on the failure model slide. These are the client tier's. Ingress: a co-located producer uses IPC to its own member and UDP to the leader otherwise; Java and C# replace the session when leadership moves off the co-located member, C++ swaps only its publication and follows a follower's redirect. A send spins through an election rather than dropping the frame. A session the cluster closed is replaced, one attempt a second, and the instance fences after 20 s without one; a gateway instance that announced itself on the lost session fences at once, since its sibling may already be designated. PendingSends resends what the old leader lost, exactly once and in order. The gateway pair and the leader-only work of applications move with the log. A gateway host's relay moves to the next member's archive and resumes at the same position, valid because every member's active recording starts at globalSeqNo 1. A client's own Replayer, queue and media driver have no alternative: an instance that acts fences. A fenced gateway instance's standby takes over at once; nothing replaces a fenced leader's application replica, so that application's leader-only work waits until the replica restarts and catches up, or leadership moves to another member.</a:t>
             </a:r>
           </a:p>
         </p:txBody>
@@ -1974,7 +1974,7 @@
           <a:lstStyle/>
           <a:p>
             <a:r>
-              <a:t>Seven members is bounded by the 70-port cluster block. Payloads above 8,884 bytes are split by the application, which keeps a frame within one IPC MTU. Four concurrent replays per member, one while the recording trails the tap; more queue. Nothing on the wire is authenticated or encrypted: the network is the access control, so the port block belongs inside a trusted network. No latency, throughput or sizing figures have been measured on production hardware yet. A change to seqeron's own protocol moves every member, gateway host and client together on purged archives; applications upgrade independently.</a:t>
+              <a:t>Seven members is bounded by the 70-port cluster block. Payloads above 8,884 bytes are split by the application, which keeps a frame within one IPC MTU. Four concurrent replays per member, one while the recording trails the queue; more wait. Nothing on the wire is authenticated or encrypted: the network is the access control, so the port block belongs inside a trusted network. No latency, throughput or sizing figures have been measured on production hardware yet. A change to seqeron's own protocol moves every member, gateway host and client together on purged archives; applications upgrade independently.</a:t>
             </a:r>
           </a:p>
         </p:txBody>
@@ -2114,7 +2114,7 @@
           <a:lstStyle/>
           <a:p>
             <a:r>
-              <a:t>Per message, every member writes the Raft log entry and the tap frame, each in a 32-byte-aligned Aeron frame with a 32-byte header. The log entry carries Aeron Cluster's 32-byte session header and seqeron's 28-byte ingress envelope; the tap frame carries the 44-byte sequenced envelope. The illustration is an estimate of Nasdaq's Nordic cash-equity market on INET, and arithmetic, not a measurement. Nasdaq's May 2024 statistics report 611,613 share trades a trading day across the Nordic and Baltic exchanges. Order messages per trade (entries, amends, cancels) were measured at 11 to 16 on the 50 most-traded Nordic stocks in 2010 to 2012; assuming 40 today gives about 25 million messages a day, some 800 a second averaged over the trading day, with the open and the close far above that. The payload is 32 bytes: a full day of Nasdaq's US ITCH 5.0 feed averages 28.5 bytes a message, and Nordic OUCH 5's order entry messages, weighted by that day's mix, 28 to 37 (Enter Order 41 bytes before optional fields, Replace 25, Cancel 15). That is 128 plus 128 bytes a message: 6.4 GB a day on each member, 1.6 TB over 250 trading days. At these sizes the 32-byte alignment dominates: a 64-byte payload would make it 8 GB. Derivatives, ETFs and warrants are not included. Every start of a member replays the log from globalSeqNo 1 into a new tap recording, and the earlier recordings stay on disk unread, so restarts add a full copy each. A member's restart time is its Raft log divided by the replay rate, which is not measured. Cluster snapshots and truncation (snapshot.md, section 10) would bound both, and are designed, not built.</a:t>
+              <a:t>Per message, every member writes the Raft log entry and the queue frame, each in a 32-byte-aligned Aeron frame with a 32-byte header. The log entry carries Aeron Cluster's 32-byte session header and seqeron's 28-byte ingress envelope; the queue frame carries the 44-byte sequenced envelope. The illustration is an estimate of Nasdaq's Nordic cash-equity market on INET, and arithmetic, not a measurement. Nasdaq's May 2024 statistics report 611,613 share trades a trading day across the Nordic and Baltic exchanges. Order messages per trade (entries, amends, cancels) were measured at 11 to 16 on the 50 most-traded Nordic stocks in 2010 to 2012; assuming 40 today gives about 25 million messages a day, some 800 a second averaged over the trading day, with the open and the close far above that. The payload is 32 bytes: a full day of Nasdaq's US ITCH 5.0 feed averages 28.5 bytes a message, and Nordic OUCH 5's order entry messages, weighted by that day's mix, 28 to 37 (Enter Order 41 bytes before optional fields, Replace 25, Cancel 15). That is 128 plus 128 bytes a message: 6.4 GB a day on each member, 1.6 TB over 250 trading days. At these sizes the 32-byte alignment dominates: a 64-byte payload would make it 8 GB. Derivatives, ETFs and warrants are not included. Every start of a member replays the log from globalSeqNo 1 into a new queue recording, and the earlier recordings stay on disk unread, so restarts add a full copy each. A member's restart time is its Raft log divided by the replay rate, which is not measured. Cluster snapshots and truncation (snapshot.md, section 10) would bound both, and are designed, not built.</a:t>
             </a:r>
           </a:p>
         </p:txBody>
@@ -2534,7 +2534,7 @@
           <a:lstStyle/>
           <a:p>
             <a:r>
-              <a:t>A publication writes into a log buffer: a memory-mapped file of three rotating terms. Offering is a copy into the current term plus an ordered write, with no lock and no system call. Position is the byte offset into the stream; flow control, loss detection, recording and replay all speak in positions. When the slowest subscriber the publication must wait for is a full window behind, offer returns back-pressured and the publisher decides what to do. Tethered versus untethered matters to seqeron: its archive is the tap's one tethered subscriber; every client is untethered.</a:t>
+              <a:t>A publication writes into a log buffer: a memory-mapped file of three rotating terms. Offering is a copy into the current term plus an ordered write, with no lock and no system call. Position is the byte offset into the stream; flow control, loss detection, recording and replay all speak in positions. When the slowest subscriber the publication must wait for is a full window behind, offer returns back-pressured and the publisher decides what to do. Tethered versus untethered matters to seqeron: its archive is the queue's one tethered subscriber; every client is untethered.</a:t>
             </a:r>
           </a:p>
         </p:txBody>
@@ -2674,7 +2674,7 @@
           <a:lstStyle/>
           <a:p>
             <a:r>
-              <a:t>The archive records any stream to segment files and keeps a catalog of recordings with ids and start and stop positions. A replay starts from any position onto any channel and stream as a new session, and a replay of a recording that is still being written follows it live. The RecordingPos counter shows how far a recording has got: seqeron's tap publisher watches exactly that counter to decide whether its archive is slow, stalled or gone.</a:t>
+              <a:t>The archive records any stream to segment files and keeps a catalog of recordings with ids and start and stop positions. A replay starts from any position onto any channel and stream as a new session, and a replay of a recording that is still being written follows it live. The RecordingPos counter shows how far a recording has got: seqeron's queue publisher watches exactly that counter to decide whether its archive is slow, stalled or gone.</a:t>
             </a:r>
           </a:p>
         </p:txBody>
@@ -2744,7 +2744,7 @@
           <a:lstStyle/>
           <a:p>
             <a:r>
-              <a:t>Sequencer owns globalSeqNo, the gateway list and session bindings, promotion deadlines and the snapshot policy; it validates and encodes every frame and hands each to a sink in globalSeqNo order, the event's own frame first and whatever it triggered behind it. SequencerService is the ClusteredService adapter: the sink is the tap, and it holds no replicated state and decides no frame order. TapPublisher is the reliable-offer discipline for the tap. The rule underneath all of it is spec S-3: every reject decision and every byte of every synthesized frame is a function of the committed log alone.</a:t>
+              <a:t>Sequencer owns globalSeqNo, the gateway list and session bindings, promotion deadlines and the snapshot policy; it validates and encodes every frame and hands each to a sink in globalSeqNo order, the event's own frame first and whatever it triggered behind it. SequencerService is the ClusteredService adapter: the sink is the queue, and it holds no replicated state and decides no frame order. QueuePublisher is the reliable-offer discipline for the queue. The rule underneath all of it is spec S-3: every reject decision and every byte of every synthesized frame is a function of the committed log alone.</a:t>
             </a:r>
           </a:p>
         </p:txBody>
@@ -2954,7 +2954,7 @@
           <a:lstStyle/>
           <a:p>
             <a:r>
-              <a:t>The alternatives are compared on properties. Kafka on one partition gives a total order and mature tooling, but no clock that advances while producers are silent and no active/standby producer election. Aeron without clustering gives reliable UDP and IPC transport with recording and replay, but no replication: the sequencer is one process and a single point of failure. Aeron Cluster used directly gives the same consensus and log, but each cluster then rebuilds the tap, replay, the election, confirmed ingress and the fences; the slide Aeron Cluster used directly is that list. A database sequence is familiar and transactional, but sequences skip values on rollback, so the order is not gap-free, and every message is a database write.</a:t>
+              <a:t>The alternatives are compared on properties. Kafka on one partition gives a total order and mature tooling, but no clock that advances while producers are silent and no active/standby producer election. Aeron without clustering gives reliable UDP and IPC transport with recording and replay, but no replication: the sequencer is one process and a single point of failure. Aeron Cluster used directly gives the same consensus and log, but each cluster then rebuilds the queue, replay, the election, confirmed ingress and the fences; the slide Aeron Cluster used directly is that list. A database sequence is familiar and transactional, but sequences skip values on rollback, so the order is not gap-free, and every message is a database write.</a:t>
             </a:r>
           </a:p>
         </p:txBody>
@@ -3024,7 +3024,7 @@
           <a:lstStyle/>
           <a:p>
             <a:r>
-              <a:t>The Replayer is ready once its active recording is visible. A client's cold start asks for the active recording FROM_START, under the clientId it drew from its media driver; the Replayer starts a replay bounded at the recording's end as it is now and answers Replaying with the replay session and catchUpPosition, echoing the requestId. The client subscribes to stream 201 for that session only, so it never holds up another client's replay. Its first frame must be globalSeqNo 1, or the client stops: the recording is short. Live tap frames past the end arrive meanwhile and go into the retained FIFO. Completion is by position, not by the image closing: a bounded replay of a recording still being written does not close at its bound. Closing the replay subscription frees the slot; the FIFO drains, de-duplicated on globalSeqNo, and the client is caught up. An empty recording answers NO_REPLAY_NEEDED and the client follows the tap at once.</a:t>
+              <a:t>The Replayer is ready once its active recording is visible. A client's cold start asks for the active recording FROM_START, under the clientId it drew from its media driver; the Replayer starts a replay bounded at the recording's end as it is now and answers Replaying with the replay session and catchUpPosition, echoing the requestId. The client subscribes to stream 201 for that session only, so it never holds up another client's replay. Its first frame must be globalSeqNo 1, or the client stops: the recording is short. Live queue frames past the end arrive meanwhile and go into the retained FIFO. Completion is by position, not by the image closing: a bounded replay of a recording still being written does not close at its bound. Closing the replay subscription frees the slot; the FIFO drains, de-duplicated on globalSeqNo, and the client is caught up. An empty recording answers NO_REPLAY_NEEDED and the client follows the queue at once.</a:t>
             </a:r>
           </a:p>
         </p:txBody>
@@ -3164,7 +3164,7 @@
           <a:lstStyle/>
           <a:p>
             <a:r>
-              <a:t>Target rule: the lowest preference rank among siblings, excluding the instance that lost the role, so a pair whose instances were all down converges on whichever starts first. The activation timeout arms at the GatewayActive's timestamp plus 5 s on the consensus clock and is evaluated on each heartbeat, which hands over every overdue deadline, each gateway at most once, so repeated failures move down the list. Being superseded is not a failure: the instance closes its edge, keeps its session and keeps following the tap so it can be designated again. From the GatewayActive that superseded it the sequencer sequences nothing from its session (rule S-6), so it drops what it still had unconfirmed, and its session closing later promotes nothing. A fence is different: the instance no longer trusts its own view: its façade closes the edge through onStandby, releases its session, reports once and does nothing more, which promotes the standby at the fence. The application decides when to exit; the repository's convention is code 70.</a:t>
+              <a:t>Target rule: the lowest preference rank among siblings, excluding the instance that lost the role, so a pair whose instances were all down converges on whichever starts first. The activation timeout arms at the GatewayActive's timestamp plus 5 s on the consensus clock and is evaluated on each heartbeat, which hands over every overdue deadline, each gateway at most once, so repeated failures move down the list. Being superseded is not a failure: the instance closes its edge, keeps its session and keeps following the queue so it can be designated again. From the GatewayActive that superseded it the sequencer sequences nothing from its session (rule S-6), so it drops what it still had unconfirmed, and its session closing later promotes nothing. A fence is different: the instance no longer trusts its own view: its façade closes the edge through onStandby, releases its session, reports once and does nothing more, which promotes the standby at the fence. The application decides when to exit; the repository's convention is code 70.</a:t>
             </a:r>
           </a:p>
         </p:txBody>
@@ -3234,7 +3234,7 @@
           <a:lstStyle/>
           <a:p>
             <a:r>
-              <a:t>An application runs one instance on every member, attached to that member's media driver, and a member can host several applications, each with its own sourceId and client id. Every instance follows its own member's tap and so holds the same state. LeadershipChanged picks the instance that acts: only the one on the leader's member publishes, over IPC ingress to its own consensus module, and every leadership change closes its gate, so a reply lost in the election is dispatched again. Remote, the application is the one instance on its own host, with no member there. Like a remote gateway's host, that host runs a local ReplayerService whose TapRelay copies a member's tap onto the host's own tap and archive. The application's gate opens once caught up, whoever leads, and it submits over UDP. Nothing elects between two remote instances, so a remote service that needs a standby is a gateway.</a:t>
+              <a:t>An application runs one instance on every member, attached to that member's media driver, and a member can host several applications, each with its own sourceId and client id. Every instance follows its own member's queue and so holds the same state. LeadershipChanged picks the instance that acts: only the one on the leader's member publishes, over IPC ingress to its own consensus module, and every leadership change closes its gate, so a reply lost in the election is dispatched again. Remote, the application is the one instance on its own host, with no member there. Like a remote gateway's host, that host runs a local ReplayerService whose QueueRelay copies a member's queue onto the host's own queue and archive. The application's gate opens once caught up, whoever leads, and it submits over UDP. Nothing elects between two remote instances, so a remote service that needs a standby is a gateway.</a:t>
             </a:r>
           </a:p>
         </p:txBody>
@@ -3304,7 +3304,7 @@
           <a:lstStyle/>
           <a:p>
             <a:r>
-              <a:t>A gateway or application host, with clients but no member, runs its own ReplayerServer with a media driver and archive. One archive replay over UDP follows a member's active recording live and republishes it on the host's own tap. TapRelay republishes only the frame after the last one it published, so the host's tap is the log frame for frame whichever member it came from. After 3 s with no frame (three heartbeats), or a failed read, it fails over to the next member archive in replayer.archiveEndpoints, round robin; any member serves, leader or not. It resumes at the same recording position, valid because every member's active recording starts at globalSeqNo 1 and positions follow from the frames; if the frame there is not the next one it replays that recording from its start and skips what it has. A restarted relay relays from 1 into a new local recording.</a:t>
+              <a:t>A gateway or application host, with clients but no member, runs its own ReplayerServer with a media driver and archive. One archive replay over UDP follows a member's active recording live and republishes it on the host's own queue. QueueRelay republishes only the frame after the last one it published, so the host's queue is the log frame for frame whichever member it came from. After 3 s with no frame (three heartbeats), or a failed read, it fails over to the next member archive in replayer.archiveEndpoints, round robin; any member serves, leader or not. It resumes at the same recording position, valid because every member's active recording starts at globalSeqNo 1 and positions follow from the frames; if the frame there is not the next one it replays that recording from its start and skips what it has. A restarted relay relays from 1 into a new local recording.</a:t>
             </a:r>
           </a:p>
         </p:txBody>
@@ -3374,7 +3374,7 @@
           <a:lstStyle/>
           <a:p>
             <a:r>
-              <a:t>The cluster closes a client's session when its keep-alives stop: a paused process, a lost quorum. Closing the session a designated instance's GatewayStarted bound is what promotes its sibling, and the tap carries no frame for that close, so a new session could act before the instance knew whether it had been superseded. That instance fences. Every other client, an application, a standby, or an instance designated after its session was lost, opens a new session the way it opened the first: an attempt at most once a second, advanced a step per doWork(), so the duty cycle never waits on an unreachable cluster. It fences only if no session opens within 20 s and the attempt then under way fails. What was unconfirmed on the old session is dropped, not resent. session-replace-test.sh drives it through a paused client, a lost quorum and a paused gateway pair, in Java.</a:t>
+              <a:t>The cluster closes a client's session when its keep-alives stop: a paused process, a lost quorum. Closing the session a designated instance's GatewayStarted bound is what promotes its sibling, and the queue carries no frame for that close, so a new session could act before the instance knew whether it had been superseded. That instance fences. Every other client, an application, a standby, or an instance designated after its session was lost, opens a new session the way it opened the first: an attempt at most once a second, advanced a step per doWork(), so the duty cycle never waits on an unreachable cluster. It fences only if no session opens within 20 s and the attempt then under way fails. What was unconfirmed on the old session is dropped, not resent. session-replace-test.sh drives it through a paused client, a lost quorum and a paused gateway pair, in Java.</a:t>
             </a:r>
           </a:p>
         </p:txBody>
@@ -3514,7 +3514,7 @@
           <a:lstStyle/>
           <a:p>
             <a:r>
-              <a:t>Every reply echoes the requestId; a client ignores any reply that is not for its current request. ReplayPending means the request is queued or the Replayer cannot start it yet: four replays at most, one while the tap's recording trails the tap by more than a quarter of the publication window, not ready before its active recording is visible, a resume position the recording has not reached yet, or an archive call that threw, which is counted. The client's resend every 500 ms is the retry, and a queued request starts once a slot frees. A resume the Replayer refuses, NO_REPLAY_NEEDED for a position, means the recording does not match the positions the client holds, and the client stops, as it does when a resume opens on the wrong frame. A replay that stops under the client, no progress for 5 s or an image closed short of catchUpPosition, is requested again; a resume re-anchors. Nothing dispatched for 30 s raises the recoveryStalled gauge; a façade fences RECOVERY_STALLED after 60 s on a designated instance or the leader's replica, above the driver's 10 s liveness timeout that frees a dead client's slot.</a:t>
+              <a:t>Every reply echoes the requestId; a client ignores any reply that is not for its current request. ReplayPending means the request is pending or the Replayer cannot start it yet: four replays at most, one while the queue's recording trails the queue by more than a quarter of the publication window, not ready before its active recording is visible, a resume position the recording has not reached yet, or an archive call that threw, which is counted. The client's resend every 500 ms is the retry, and a pending request starts once a slot frees. A resume the Replayer refuses, NO_REPLAY_NEEDED for a position, means the recording does not match the positions the client holds, and the client stops, as it does when a resume opens on the wrong frame. A replay that stops under the client, no progress for 5 s or an image closed short of catchUpPosition, is requested again; a resume re-anchors. Nothing dispatched for 30 s raises the recoveryStalled gauge; a façade fences RECOVERY_STALLED after 60 s on a designated instance or the leader's replica, above the driver's 10 s liveness timeout that frees a dead client's slot.</a:t>
             </a:r>
           </a:p>
         </p:txBody>
@@ -3864,7 +3864,7 @@
           <a:lstStyle/>
           <a:p>
             <a:r>
-              <a:t>An application brings its own protocol in the application family. payloadId names one schema or encoding, allocated by the deployment from 2 up; 0 is invalid and 1 is retired. The producer encodes the payload once and nothing re-encodes it, so any encoding works and its versioning is the application's own. The table is what Application does on the application's behalf, in every language. It submits application frames only while its leader gate is open; a reply goes out under the requester's sourceId and connectionId so the gateway that took the request can route it. Every frame on the tap also passes confirmed ingress, which matches the replica's own frames by cluster session. LeadershipChanged reaches the gate and confirmed ingress, never the application directly; the listener sees only the gate's edges. The consumer rules keep applications independent: a consumer skips what it does not recognise, and since continuity rests on globalSeqNo, skipping can neither create nor hide a gap. A PayloadIdRegistered row in the topology is a label for SbeLogPrinter, not permission; a per-node allowlist would let nodes diverge. The snapshot frames it reads and submits are on the snapshot protocol slide.</a:t>
+              <a:t>An application brings its own protocol in the application family. payloadId names one schema or encoding, allocated by the deployment from 2 up; 0 is invalid and 1 is retired. The producer encodes the payload once and nothing re-encodes it, so any encoding works and its versioning is the application's own. The table is what Application does on the application's behalf, in every language. It submits application frames only while its leader gate is open; a reply goes out under the requester's sourceId and connectionId so the gateway that took the request can route it. Every frame on the queue also passes confirmed ingress, which matches the replica's own frames by cluster session. LeadershipChanged reaches the gate and confirmed ingress, never the application directly; the listener sees only the gate's edges. The consumer rules keep applications independent: a consumer skips what it does not recognise, and since continuity rests on globalSeqNo, skipping can neither create nor hide a gap. A PayloadIdRegistered row in the topology is a label for SbeLogPrinter, not permission; a per-node allowlist would let nodes diverge. The snapshot frames it reads and submits are on the snapshot protocol slide.</a:t>
             </a:r>
           </a:p>
         </p:txBody>
@@ -3934,7 +3934,7 @@
           <a:lstStyle/>
           <a:p>
             <a:r>
-              <a:t>Each fence is reported once through onFenced. Before it, the façade closes what lets the instance act, a serving gateway's edge through onStandby or an application's open gate through onLeadershipChanged(false), and releases its cluster session, so a designated instance's standby is promoted at the fence. At the end of that duty cycle it releases its tap and replay subscriptions, so a fenced instance holds no Replayer slot. Exiting is the application's decision; the examples exit with 70, the repository's convention for fenced, restart me. The tap-stall timer runs on local monotonic time because consensus time arrives in the very heartbeats being watched for. A replay is not a stall: the tap-stall check is suspended while not caught up, and the recovery-stall fence covers that time, armed only after the first catch-up because a cold start has no useful bound. 60 s exceeds the driver's 10 s liveness timeout, the longest a dead client holds a replay slot, so a correct Replayer cannot trip it. A stall fences only an instance that acts, the designated gateway instance or the leader's replica; any other logs it once, keeps following the tap and logs when it clears, since it cannot begin to act while stalled. A lost session fences only a gateway instance that announced itself on it; the slide on lost sessions covers the rest. Losing the media driver is not a fence; it raises from doWork().</a:t>
+              <a:t>Each fence is reported once through onFenced. Before it, the façade closes what lets the instance act, a serving gateway's edge through onStandby or an application's open gate through onLeadershipChanged(false), and releases its cluster session, so a designated instance's standby is promoted at the fence. At the end of that duty cycle it releases its queue and replay subscriptions, so a fenced instance holds no Replayer slot. Exiting is the application's decision; the examples exit with 70, the repository's convention for fenced, restart me. The queue-stall timer runs on local monotonic time because consensus time arrives in the very heartbeats being watched for. A replay is not a stall: the queue-stall check is suspended while not caught up, and the recovery-stall fence covers that time, armed only after the first catch-up because a cold start has no useful bound. 60 s exceeds the driver's 10 s liveness timeout, the longest a dead client holds a replay slot, so a correct Replayer cannot trip it. A stall fences only an instance that acts, the designated gateway instance or the leader's replica; any other logs it once, keeps following the queue and logs when it clears, since it cannot begin to act while stalled. A lost session fences only a gateway instance that announced itself on it; the slide on lost sessions covers the rest. Losing the media driver is not a fence; it raises from doWork().</a:t>
             </a:r>
           </a:p>
         </p:txBody>
@@ -4074,7 +4074,7 @@
           <a:lstStyle/>
           <a:p>
             <a:r>
-              <a:t>Point to land: everything in the rest of the talk is built from these three. Explicit back-pressure lets the tap be reliable but bounded. Local recording with replay by position makes every member a complete history server. A replicated log with deterministic time makes the order, the clock and the gateway election the same on every node. Aeron, Agrona and SBE are open source under Apache 2.0.</a:t>
+              <a:t>Point to land: everything in the rest of the talk is built from these three. Explicit back-pressure lets the queue be reliable but bounded. Local recording with replay by position makes every member a complete history server. A replicated log with deterministic time makes the order, the clock and the gateway election the same on every node. Aeron, Agrona and SBE are open source under Apache 2.0.</a:t>
             </a:r>
           </a:p>
         </p:txBody>
@@ -4214,7 +4214,7 @@
           <a:lstStyle/>
           <a:p>
             <a:r>
-              <a:t>Each member is one JVM: consensus module, sequencer, embedded media driver, archive and Replayer. Live data reaches a client straight off the tap, untethered. History comes from the member's own recording through the Replayer on stream 201, with requests on 202 and control replies on 203. Ingress is IPC when this member leads and UDP otherwise. Other members run the same pipeline and produce a byte-identical tap. The client tier is Java, C++ and C#, with C# deployed on Windows too; the member is Java only.</a:t>
+              <a:t>Each member is one JVM: consensus module, sequencer, embedded media driver, archive and Replayer. Live data reaches a client straight off the queue, untethered. History comes from the member's own recording through the Replayer on stream 201, with requests on 202 and control replies on 203. Ingress is IPC when this member leads and UDP otherwise. Other members run the same pipeline and produce a byte-identical queue. The client tier is Java, C++ and C#, with C# deployed on Windows too; the member is Java only.</a:t>
             </a:r>
           </a:p>
         </p:txBody>
@@ -4284,7 +4284,7 @@
           <a:lstStyle/>
           <a:p>
             <a:r>
-              <a:t>1. IngressPublisher wraps the producer's own encoding in an Unsequenced frame and offers it. 2. The leader appends it to the Raft log; it commits at a majority. 3. Every cluster member's sequencer validates it and assigns the next globalSeqNo and consensus timestamp. 4. Every archive records it. 5. Each client reads it off its local tap, checks continuity, dispatches. 6. The producer sees its own frame on its tap; only then is the message known to be sequenced. A cold start runs steps 5 and 6 against a replay first.</a:t>
+              <a:t>1. IngressPublisher wraps the producer's own encoding in an Unsequenced frame and offers it. 2. The leader appends it to the Raft log; it commits at a majority. 3. Every cluster member's sequencer validates it and assigns the next globalSeqNo and consensus timestamp. 4. Every archive records it. 5. Each client reads it off its local queue, checks continuity, dispatches. 6. The producer sees its own frame on its queue; only then is the message known to be sequenced. A cold start runs steps 5 and 6 against a replay first.</a:t>
             </a:r>
           </a:p>
         </p:txBody>
@@ -8154,7 +8154,7 @@
                 </a:solidFill>
                 <a:latin typeface="+mj-lt"/>
               </a:rPr>
-              <a:t>The tap</a:t>
+              <a:t>The queue</a:t>
             </a:r>
           </a:p>
         </p:txBody>
@@ -8214,7 +8214,7 @@
           <a:lstStyle/>
           <a:p>
             <a:pPr algn="r"/>
-            <a:fld id="{b9e631ef-5868-4c48-be55-60cfc5fd83b3}" type="slidenum">
+            <a:fld id="{8ced28fc-ef69-4e09-a67d-eb96fe5b0bed}" type="slidenum">
               <a:rPr lang="en-US" sz="1000" dirty="0">
                 <a:solidFill>
                   <a:schemeClr val="accent5"/>
@@ -8378,14 +8378,14 @@
                   <a:schemeClr val="accent1"/>
                 </a:solidFill>
               </a:rPr>
-              <a:t>Tap 205</a:t>
-            </a:r>
-          </a:p>
-        </p:txBody>
-      </p:sp>
-      <p:sp>
-        <p:nvSpPr>
-          <p:cNvPr id="9015" name="Tap cell 160"/>
+              <a:t>Queue 205</a:t>
+            </a:r>
+          </a:p>
+        </p:txBody>
+      </p:sp>
+      <p:sp>
+        <p:nvSpPr>
+          <p:cNvPr id="9015" name="Queue cell 160"/>
           <p:cNvSpPr/>
           <p:nvPr/>
         </p:nvSpPr>
@@ -8439,7 +8439,7 @@
       </p:sp>
       <p:sp>
         <p:nvSpPr>
-          <p:cNvPr id="9016" name="Tap cell 161"/>
+          <p:cNvPr id="9016" name="Queue cell 161"/>
           <p:cNvSpPr/>
           <p:nvPr/>
         </p:nvSpPr>
@@ -8493,7 +8493,7 @@
       </p:sp>
       <p:sp>
         <p:nvSpPr>
-          <p:cNvPr id="9017" name="Tap cell 162"/>
+          <p:cNvPr id="9017" name="Queue cell 162"/>
           <p:cNvSpPr/>
           <p:nvPr/>
         </p:nvSpPr>
@@ -8547,7 +8547,7 @@
       </p:sp>
       <p:sp>
         <p:nvSpPr>
-          <p:cNvPr id="9018" name="Tap cell 163"/>
+          <p:cNvPr id="9018" name="Queue cell 163"/>
           <p:cNvSpPr/>
           <p:nvPr/>
         </p:nvSpPr>
@@ -8601,7 +8601,7 @@
       </p:sp>
       <p:sp>
         <p:nvSpPr>
-          <p:cNvPr id="9019" name="Tap cell 164"/>
+          <p:cNvPr id="9019" name="Queue cell 164"/>
           <p:cNvSpPr/>
           <p:nvPr/>
         </p:nvSpPr>
@@ -8653,7 +8653,7 @@
       </p:sp>
       <p:sp>
         <p:nvSpPr>
-          <p:cNvPr id="9020" name="Tap cell 165"/>
+          <p:cNvPr id="9020" name="Queue cell 165"/>
           <p:cNvSpPr/>
           <p:nvPr/>
         </p:nvSpPr>
@@ -8699,7 +8699,7 @@
       </p:sp>
       <p:sp>
         <p:nvSpPr>
-          <p:cNvPr id="9021" name="Tap cell 166"/>
+          <p:cNvPr id="9021" name="Queue cell 166"/>
           <p:cNvSpPr/>
           <p:nvPr/>
         </p:nvSpPr>
@@ -8986,14 +8986,14 @@
                   <a:schemeClr val="accent1"/>
                 </a:solidFill>
               </a:rPr>
-              <a:t>Tap 205</a:t>
-            </a:r>
-          </a:p>
-        </p:txBody>
-      </p:sp>
-      <p:sp>
-        <p:nvSpPr>
-          <p:cNvPr id="9028" name="Tap cell 173"/>
+              <a:t>Queue 205</a:t>
+            </a:r>
+          </a:p>
+        </p:txBody>
+      </p:sp>
+      <p:sp>
+        <p:nvSpPr>
+          <p:cNvPr id="9028" name="Queue cell 173"/>
           <p:cNvSpPr/>
           <p:nvPr/>
         </p:nvSpPr>
@@ -9047,7 +9047,7 @@
       </p:sp>
       <p:sp>
         <p:nvSpPr>
-          <p:cNvPr id="9029" name="Tap cell 174"/>
+          <p:cNvPr id="9029" name="Queue cell 174"/>
           <p:cNvSpPr/>
           <p:nvPr/>
         </p:nvSpPr>
@@ -9101,7 +9101,7 @@
       </p:sp>
       <p:sp>
         <p:nvSpPr>
-          <p:cNvPr id="9030" name="Tap cell 175"/>
+          <p:cNvPr id="9030" name="Queue cell 175"/>
           <p:cNvSpPr/>
           <p:nvPr/>
         </p:nvSpPr>
@@ -9155,7 +9155,7 @@
       </p:sp>
       <p:sp>
         <p:nvSpPr>
-          <p:cNvPr id="9031" name="Tap cell 176"/>
+          <p:cNvPr id="9031" name="Queue cell 176"/>
           <p:cNvSpPr/>
           <p:nvPr/>
         </p:nvSpPr>
@@ -9209,7 +9209,7 @@
       </p:sp>
       <p:sp>
         <p:nvSpPr>
-          <p:cNvPr id="9032" name="Tap cell 177"/>
+          <p:cNvPr id="9032" name="Queue cell 177"/>
           <p:cNvSpPr/>
           <p:nvPr/>
         </p:nvSpPr>
@@ -9261,7 +9261,7 @@
       </p:sp>
       <p:sp>
         <p:nvSpPr>
-          <p:cNvPr id="9033" name="Tap cell 178"/>
+          <p:cNvPr id="9033" name="Queue cell 178"/>
           <p:cNvSpPr/>
           <p:nvPr/>
         </p:nvSpPr>
@@ -9307,7 +9307,7 @@
       </p:sp>
       <p:sp>
         <p:nvSpPr>
-          <p:cNvPr id="9034" name="Tap cell 179"/>
+          <p:cNvPr id="9034" name="Queue cell 179"/>
           <p:cNvSpPr/>
           <p:nvPr/>
         </p:nvSpPr>
@@ -9594,14 +9594,14 @@
                   <a:schemeClr val="accent1"/>
                 </a:solidFill>
               </a:rPr>
-              <a:t>Tap 205</a:t>
-            </a:r>
-          </a:p>
-        </p:txBody>
-      </p:sp>
-      <p:sp>
-        <p:nvSpPr>
-          <p:cNvPr id="9041" name="Tap cell 186"/>
+              <a:t>Queue 205</a:t>
+            </a:r>
+          </a:p>
+        </p:txBody>
+      </p:sp>
+      <p:sp>
+        <p:nvSpPr>
+          <p:cNvPr id="9041" name="Queue cell 186"/>
           <p:cNvSpPr/>
           <p:nvPr/>
         </p:nvSpPr>
@@ -9655,7 +9655,7 @@
       </p:sp>
       <p:sp>
         <p:nvSpPr>
-          <p:cNvPr id="9042" name="Tap cell 187"/>
+          <p:cNvPr id="9042" name="Queue cell 187"/>
           <p:cNvSpPr/>
           <p:nvPr/>
         </p:nvSpPr>
@@ -9709,7 +9709,7 @@
       </p:sp>
       <p:sp>
         <p:nvSpPr>
-          <p:cNvPr id="9043" name="Tap cell 188"/>
+          <p:cNvPr id="9043" name="Queue cell 188"/>
           <p:cNvSpPr/>
           <p:nvPr/>
         </p:nvSpPr>
@@ -9763,7 +9763,7 @@
       </p:sp>
       <p:sp>
         <p:nvSpPr>
-          <p:cNvPr id="9044" name="Tap cell 189"/>
+          <p:cNvPr id="9044" name="Queue cell 189"/>
           <p:cNvSpPr/>
           <p:nvPr/>
         </p:nvSpPr>
@@ -9817,7 +9817,7 @@
       </p:sp>
       <p:sp>
         <p:nvSpPr>
-          <p:cNvPr id="9045" name="Tap cell 190"/>
+          <p:cNvPr id="9045" name="Queue cell 190"/>
           <p:cNvSpPr/>
           <p:nvPr/>
         </p:nvSpPr>
@@ -9869,7 +9869,7 @@
       </p:sp>
       <p:sp>
         <p:nvSpPr>
-          <p:cNvPr id="9046" name="Tap cell 191"/>
+          <p:cNvPr id="9046" name="Queue cell 191"/>
           <p:cNvSpPr/>
           <p:nvPr/>
         </p:nvSpPr>
@@ -9915,7 +9915,7 @@
       </p:sp>
       <p:sp>
         <p:nvSpPr>
-          <p:cNvPr id="9047" name="Tap cell 192"/>
+          <p:cNvPr id="9047" name="Queue cell 192"/>
           <p:cNvSpPr/>
           <p:nvPr/>
         </p:nvSpPr>
@@ -10082,7 +10082,7 @@
                   <a:schemeClr val="tx1"/>
                 </a:solidFill>
               </a:rPr>
-              <a:t>Same committed log → byte-identical taps → every archive holds full history.</a:t>
+              <a:t>Same committed log → byte-identical queues → every archive holds full history.</a:t>
             </a:r>
           </a:p>
           <a:p>
@@ -10093,7 +10093,7 @@
                   <a:schemeClr val="accent5"/>
                 </a:solidFill>
               </a:rPr>
-              <a:t>The tap survives leadership changes: one continuous recording per member.</a:t>
+              <a:t>The queue survives leadership changes: one continuous recording per member.</a:t>
             </a:r>
           </a:p>
         </p:txBody>
@@ -10509,7 +10509,7 @@
                 </a:solidFill>
                 <a:latin typeface="+mj-lt"/>
               </a:rPr>
-              <a:t>Live from tap and history from archive</a:t>
+              <a:t>Live from queue and history from archive</a:t>
             </a:r>
           </a:p>
         </p:txBody>
@@ -10569,7 +10569,7 @@
           <a:lstStyle/>
           <a:p>
             <a:pPr algn="r"/>
-            <a:fld id="{4dd69180-b3a9-4a8e-9aa8-fa618e6de800}" type="slidenum">
+            <a:fld id="{f5ada086-72df-4d47-85a5-5b8734019777}" type="slidenum">
               <a:rPr lang="en-US" sz="1000" dirty="0">
                 <a:solidFill>
                   <a:schemeClr val="accent5"/>
@@ -10679,7 +10679,7 @@
         <p:spPr>
           <a:xfrm>
             <a:off x="548640" y="1810512"/>
-            <a:ext cx="1280160" cy="219456"/>
+            <a:ext cx="1737360" cy="219456"/>
           </a:xfrm>
           <a:prstGeom prst="rect">
             <a:avLst/>
@@ -10699,14 +10699,14 @@
                   <a:schemeClr val="accent1"/>
                 </a:solidFill>
               </a:rPr>
-              <a:t>Tap · aeron:ipc 205</a:t>
-            </a:r>
-          </a:p>
-        </p:txBody>
-      </p:sp>
-      <p:sp>
-        <p:nvSpPr>
-          <p:cNvPr id="9015" name="Tap cell 203"/>
+              <a:t>Queue · aeron:ipc 205</a:t>
+            </a:r>
+          </a:p>
+        </p:txBody>
+      </p:sp>
+      <p:sp>
+        <p:nvSpPr>
+          <p:cNvPr id="9015" name="Queue cell 203"/>
           <p:cNvSpPr/>
           <p:nvPr/>
         </p:nvSpPr>
@@ -10760,7 +10760,7 @@
       </p:sp>
       <p:sp>
         <p:nvSpPr>
-          <p:cNvPr id="9016" name="Tap cell 204"/>
+          <p:cNvPr id="9016" name="Queue cell 204"/>
           <p:cNvSpPr/>
           <p:nvPr/>
         </p:nvSpPr>
@@ -10814,7 +10814,7 @@
       </p:sp>
       <p:sp>
         <p:nvSpPr>
-          <p:cNvPr id="9017" name="Tap cell 205"/>
+          <p:cNvPr id="9017" name="Queue cell 205"/>
           <p:cNvSpPr/>
           <p:nvPr/>
         </p:nvSpPr>
@@ -10868,7 +10868,7 @@
       </p:sp>
       <p:sp>
         <p:nvSpPr>
-          <p:cNvPr id="9018" name="Tap cell 206"/>
+          <p:cNvPr id="9018" name="Queue cell 206"/>
           <p:cNvSpPr/>
           <p:nvPr/>
         </p:nvSpPr>
@@ -10922,7 +10922,7 @@
       </p:sp>
       <p:sp>
         <p:nvSpPr>
-          <p:cNvPr id="9019" name="Tap cell 207"/>
+          <p:cNvPr id="9019" name="Queue cell 207"/>
           <p:cNvSpPr/>
           <p:nvPr/>
         </p:nvSpPr>
@@ -10974,7 +10974,7 @@
       </p:sp>
       <p:sp>
         <p:nvSpPr>
-          <p:cNvPr id="9020" name="Tap cell 208"/>
+          <p:cNvPr id="9020" name="Queue cell 208"/>
           <p:cNvSpPr/>
           <p:nvPr/>
         </p:nvSpPr>
@@ -11020,7 +11020,7 @@
       </p:sp>
       <p:sp>
         <p:nvSpPr>
-          <p:cNvPr id="9021" name="Tap cell 209"/>
+          <p:cNvPr id="9021" name="Queue cell 209"/>
           <p:cNvSpPr/>
           <p:nvPr/>
         </p:nvSpPr>
@@ -12074,7 +12074,7 @@
           <a:lstStyle/>
           <a:p>
             <a:pPr algn="r"/>
-            <a:fld id="{5acedb7b-fc88-4f69-828a-4786e447c81c}" type="slidenum">
+            <a:fld id="{db8b8d4e-364e-4774-bc39-e7b0b3a2ef11}" type="slidenum">
               <a:rPr lang="en-US" sz="1000" dirty="0">
                 <a:solidFill>
                   <a:schemeClr val="accent5"/>
@@ -13166,7 +13166,7 @@
           <a:lstStyle/>
           <a:p>
             <a:pPr algn="r"/>
-            <a:fld id="{a9799ba5-0d25-4bf6-ac4a-8f8f2294c97b}" type="slidenum">
+            <a:fld id="{414b8ab9-8a4b-4056-a36b-54b210c4395c}" type="slidenum">
               <a:rPr lang="en-US" sz="1000" dirty="0">
                 <a:solidFill>
                   <a:schemeClr val="accent5"/>
@@ -13206,7 +13206,7 @@
                   <a:schemeClr val="tx1"/>
                 </a:solidFill>
               </a:rPr>
-              <a:t>Tap 205</a:t>
+              <a:t>Queue 205</a:t>
             </a:r>
           </a:p>
         </p:txBody>
@@ -14583,7 +14583,7 @@
                   <a:schemeClr val="accent5"/>
                 </a:solidFill>
               </a:rPr>
-              <a:t>105 from the replay, then the FIFO drains, then back on the live tap.</a:t>
+              <a:t>105 from the replay, then the FIFO drains, then back on the live queue.</a:t>
             </a:r>
           </a:p>
         </p:txBody>
@@ -14625,7 +14625,7 @@
                   <a:schemeClr val="tx1"/>
                 </a:solidFill>
               </a:rPr>
-              <a:t>is the same walk from globalSeqNo 1 to the reported end, then the tap, de-duplicating on globalSeqNo.</a:t>
+              <a:t>is the same walk from globalSeqNo 1 to the reported end, then the queue, de-duplicating on globalSeqNo.</a:t>
             </a:r>
           </a:p>
         </p:txBody>
@@ -14731,7 +14731,7 @@
           <a:lstStyle/>
           <a:p>
             <a:pPr algn="r"/>
-            <a:fld id="{13d8560e-7f67-428a-b629-27594a017cb8}" type="slidenum">
+            <a:fld id="{ec43ed59-75f9-4521-abe9-e678245f81d8}" type="slidenum">
               <a:rPr lang="en-US" sz="1000" dirty="0">
                 <a:solidFill>
                   <a:schemeClr val="accent5"/>
@@ -15324,7 +15324,7 @@
                   <a:schemeClr val="tx1"/>
                 </a:solidFill>
               </a:rPr>
-              <a:t>Tap + recovery</a:t>
+              <a:t>Queue + recovery</a:t>
             </a:r>
           </a:p>
         </p:txBody>
@@ -15771,7 +15771,7 @@
           <a:lstStyle/>
           <a:p>
             <a:pPr algn="r"/>
-            <a:fld id="{5c563964-efda-4882-97d8-55d5cdc789db}" type="slidenum">
+            <a:fld id="{24ed56bf-df24-43fe-a169-284a60b77cc1}" type="slidenum">
               <a:rPr lang="en-US" sz="1000" dirty="0">
                 <a:solidFill>
                   <a:schemeClr val="accent5"/>
@@ -16598,7 +16598,7 @@
           <a:lstStyle/>
           <a:p>
             <a:pPr algn="r"/>
-            <a:fld id="{aca28794-dbc0-4410-87da-144b5a5dbb23}" type="slidenum">
+            <a:fld id="{d09aaddd-b866-4c3a-aaf5-317d0f5a6ae4}" type="slidenum">
               <a:rPr lang="en-US" sz="1000" dirty="0">
                 <a:solidFill>
                   <a:schemeClr val="accent5"/>
@@ -17325,7 +17325,7 @@
                   <a:schemeClr val="tx1"/>
                 </a:solidFill>
               </a:rPr>
-              <a:t>hot standby: follows the tap, rebuilds A's connections from the log</a:t>
+              <a:t>hot standby: follows the queue, rebuilds A's connections from the log</a:t>
             </a:r>
           </a:p>
         </p:txBody>
@@ -17703,7 +17703,7 @@
           <a:lstStyle/>
           <a:p>
             <a:pPr algn="r"/>
-            <a:fld id="{0cfd04a0-cdf5-4a90-91c2-e33f4f137286}" type="slidenum">
+            <a:fld id="{aa415ebb-6b56-40db-811f-4d3bbaf3ece3}" type="slidenum">
               <a:rPr lang="en-US" sz="1000" dirty="0">
                 <a:solidFill>
                   <a:schemeClr val="accent5"/>
@@ -18801,7 +18801,7 @@
                   <a:schemeClr val="accent5"/>
                 </a:solidFill>
               </a:rPr>
-              <a:t>A failover can lose uncommitted ingress silently; the producer's own tap finds it</a:t>
+              <a:t>A failover can lose uncommitted ingress silently; the producer's own queue finds it</a:t>
             </a:r>
           </a:p>
         </p:txBody>
@@ -18827,7 +18827,7 @@
           <a:lstStyle/>
           <a:p>
             <a:pPr algn="r"/>
-            <a:fld id="{05040266-c73b-4559-98d5-fb8d1d396244}" type="slidenum">
+            <a:fld id="{1ffb6cf2-d78a-4b4c-8320-6b1b9e3dc2f8}" type="slidenum">
               <a:rPr lang="en-US" sz="1000" dirty="0">
                 <a:solidFill>
                   <a:schemeClr val="accent5"/>
@@ -18901,7 +18901,7 @@
                   <a:schemeClr val="tx1"/>
                 </a:solidFill>
               </a:rPr>
-              <a:t>Own tap shows</a:t>
+              <a:t>Own queue shows</a:t>
             </a:r>
           </a:p>
         </p:txBody>
@@ -20114,7 +20114,7 @@
                   <a:schemeClr val="tx1"/>
                 </a:solidFill>
               </a:rPr>
-              <a:t>Each frame is held until the producer's own tap shows it.</a:t>
+              <a:t>Each frame is held until the producer's own queue shows it.</a:t>
             </a:r>
           </a:p>
         </p:txBody>
@@ -20354,7 +20354,7 @@
           <a:lstStyle/>
           <a:p>
             <a:pPr algn="r"/>
-            <a:fld id="{88409763-1994-448e-9618-ac6da70a7bb6}" type="slidenum">
+            <a:fld id="{19162276-0375-45a2-b043-cf936b58d6b5}" type="slidenum">
               <a:rPr lang="en-US" sz="1000" dirty="0">
                 <a:solidFill>
                   <a:schemeClr val="accent5"/>
@@ -21489,7 +21489,7 @@
           <a:lstStyle/>
           <a:p>
             <a:pPr algn="r"/>
-            <a:fld id="{e3dc7db1-369e-4ec2-98dd-3f5bb72bf9f3}" type="slidenum">
+            <a:fld id="{a37dc5ff-a8d5-441e-8a9a-9da3c0626272}" type="slidenum">
               <a:rPr lang="en-US" sz="1000" dirty="0">
                 <a:solidFill>
                   <a:schemeClr val="accent5"/>
@@ -22076,7 +22076,7 @@
           <a:lstStyle/>
           <a:p>
             <a:pPr algn="r"/>
-            <a:fld id="{829184fc-b86e-41b5-82ef-245666802f34}" type="slidenum">
+            <a:fld id="{702385c5-704b-426a-8394-0691a1456e1c}" type="slidenum">
               <a:rPr lang="en-US" sz="1000" dirty="0">
                 <a:solidFill>
                   <a:schemeClr val="accent5"/>
@@ -22506,7 +22506,7 @@
                             <a:schemeClr val="tx1"/>
                           </a:solidFill>
                         </a:rPr>
-                        <a:t>Dropped; tap unaffected</a:t>
+                        <a:t>Dropped; queue unaffected</a:t>
                       </a:r>
                     </a:p>
                   </a:txBody>
@@ -22574,7 +22574,7 @@
                             <a:schemeClr val="tx1"/>
                           </a:solidFill>
                         </a:rPr>
-                        <a:t>Frame missed on tap</a:t>
+                        <a:t>Frame missed on queue</a:t>
                       </a:r>
                     </a:p>
                   </a:txBody>
@@ -23136,7 +23136,7 @@
                             <a:schemeClr val="tx1"/>
                           </a:solidFill>
                         </a:rPr>
-                        <a:t>Nothing commits; tap silent</a:t>
+                        <a:t>Nothing commits; queue silent</a:t>
                       </a:r>
                     </a:p>
                   </a:txBody>
@@ -23296,7 +23296,7 @@
           <a:lstStyle/>
           <a:p>
             <a:pPr algn="r"/>
-            <a:fld id="{e48d77e0-4d35-42d8-8776-4f14b86149f4}" type="slidenum">
+            <a:fld id="{f2254b0d-2639-4e7b-8f68-186aca3f68d7}" type="slidenum">
               <a:rPr lang="en-US" sz="1000" dirty="0">
                 <a:solidFill>
                   <a:schemeClr val="accent5"/>
@@ -24062,7 +24062,7 @@
           <a:lstStyle/>
           <a:p>
             <a:pPr algn="r"/>
-            <a:fld id="{75c0e7b3-dedb-4f97-85a7-f21eca619c45}" type="slidenum">
+            <a:fld id="{f02dbf29-de55-4f30-968f-a6802cb3e858}" type="slidenum">
               <a:rPr lang="en-US" sz="1000" dirty="0">
                 <a:solidFill>
                   <a:schemeClr val="accent5"/>
@@ -24569,7 +24569,7 @@
                   <a:schemeClr val="tx1"/>
                 </a:solidFill>
               </a:rPr>
-              <a:t>Tap back-pressure and stall</a:t>
+              <a:t>Queue back-pressure and stall</a:t>
             </a:r>
           </a:p>
           <a:p>
@@ -25002,7 +25002,7 @@
           <a:lstStyle/>
           <a:p>
             <a:pPr algn="r"/>
-            <a:fld id="{1ec5bcf8-7a7b-492b-b150-c98250209c82}" type="slidenum">
+            <a:fld id="{858b41ac-243d-45ab-88c9-25b6ccd532d3}" type="slidenum">
               <a:rPr lang="en-US" sz="1000" dirty="0">
                 <a:solidFill>
                   <a:schemeClr val="accent5"/>
@@ -25161,7 +25161,7 @@
                             <a:schemeClr val="tx1"/>
                           </a:solidFill>
                         </a:rPr>
-                        <a:t>Confirmed on the producer's own tap</a:t>
+                        <a:t>Confirmed on the producer's own queue</a:t>
                       </a:r>
                     </a:p>
                   </a:txBody>
@@ -26370,7 +26370,7 @@
           <a:lstStyle/>
           <a:p>
             <a:pPr algn="r"/>
-            <a:fld id="{f264a230-b807-4993-8788-e9cf1cd17292}" type="slidenum">
+            <a:fld id="{881b31bf-de38-48a2-847e-8bb305156961}" type="slidenum">
               <a:rPr lang="en-US" sz="1000" dirty="0">
                 <a:solidFill>
                   <a:schemeClr val="accent5"/>
@@ -26893,7 +26893,7 @@
                             <a:schemeClr val="tx1"/>
                           </a:solidFill>
                         </a:rPr>
-                        <a:t>Gateway host's tap relay</a:t>
+                        <a:t>Gateway host's queue relay</a:t>
                       </a:r>
                     </a:p>
                   </a:txBody>
@@ -27009,7 +27009,7 @@
                   <a:schemeClr val="tx1"/>
                 </a:solidFill>
               </a:rPr>
-              <a:t>a client's own Replayer, tap and media driver. An instance that acts fences: a gateway's standby takes over at once, but a leader's application waits for its own restart or a new leader.</a:t>
+              <a:t>a client's own Replayer, queue and media driver. An instance that acts fences: a gateway's standby takes over at once, but a leader's application waits for its own restart or a new leader.</a:t>
             </a:r>
           </a:p>
         </p:txBody>
@@ -27115,7 +27115,7 @@
           <a:lstStyle/>
           <a:p>
             <a:pPr algn="r"/>
-            <a:fld id="{9043c845-51ed-4f42-9907-b0c82bd030eb}" type="slidenum">
+            <a:fld id="{a1ae7fac-3bc2-437b-b5f0-4ce26f6d5e5f}" type="slidenum">
               <a:rPr lang="en-US" sz="1000" dirty="0">
                 <a:solidFill>
                   <a:schemeClr val="accent5"/>
@@ -27298,7 +27298,7 @@
                             <a:schemeClr val="tx1"/>
                           </a:solidFill>
                         </a:rPr>
-                        <a:t>Each member records its tap</a:t>
+                        <a:t>Each member records its queue</a:t>
                       </a:r>
                     </a:p>
                   </a:txBody>
@@ -27798,7 +27798,7 @@
           <a:lstStyle/>
           <a:p>
             <a:pPr algn="r"/>
-            <a:fld id="{5bfc52a1-196e-4e50-9e35-5feb808aa938}" type="slidenum">
+            <a:fld id="{25d10ba2-fb8a-4b97-9e1e-4e964f4f5dc0}" type="slidenum">
               <a:rPr lang="en-US" sz="1000" dirty="0">
                 <a:solidFill>
                   <a:schemeClr val="accent5"/>
@@ -28053,7 +28053,7 @@
                   <a:schemeClr val="accent5"/>
                 </a:solidFill>
               </a:rPr>
-              <a:t>1 while the recording is behind; more queue</a:t>
+              <a:t>1 while the recording is behind; more wait</a:t>
             </a:r>
           </a:p>
         </p:txBody>
@@ -28408,7 +28408,7 @@
           <a:lstStyle/>
           <a:p>
             <a:pPr algn="r"/>
-            <a:fld id="{13ff16bd-d9d9-4bce-8c8f-5f660cd1959d}" type="slidenum">
+            <a:fld id="{4dbd22b1-ad6f-4ad2-a9aa-e4ef49a53d40}" type="slidenum">
               <a:rPr lang="en-US" sz="1000" dirty="0">
                 <a:solidFill>
                   <a:schemeClr val="accent5"/>
@@ -28522,7 +28522,7 @@
                             <a:schemeClr val="tx1"/>
                           </a:solidFill>
                         </a:rPr>
-                        <a:t>Ingress to the producer's own tap: not measured</a:t>
+                        <a:t>Ingress to the producer's own queue: not measured</a:t>
                       </a:r>
                     </a:p>
                   </a:txBody>
@@ -28934,7 +28934,7 @@
                   <a:schemeClr val="accent5"/>
                 </a:solidFill>
               </a:rPr>
-              <a:t>Every member records the Raft log and the tap, and keeps both</a:t>
+              <a:t>Every member records the Raft log and the queue, and keeps both</a:t>
             </a:r>
           </a:p>
         </p:txBody>
@@ -28960,7 +28960,7 @@
           <a:lstStyle/>
           <a:p>
             <a:pPr algn="r"/>
-            <a:fld id="{4baa2ff3-1e7b-45cd-92e9-ff643e29e3df}" type="slidenum">
+            <a:fld id="{7008703a-2e38-44c8-a381-895fbfbfb6c8}" type="slidenum">
               <a:rPr lang="en-US" sz="1000" dirty="0">
                 <a:solidFill>
                   <a:schemeClr val="accent5"/>
@@ -29061,7 +29061,7 @@
                   <a:schemeClr val="tx1"/>
                 </a:solidFill>
               </a:rPr>
-              <a:t>Tap frame   </a:t>
+              <a:t>Queue frame   </a:t>
             </a:r>
             <a:r>
               <a:rPr sz="1600" b="1">
@@ -29265,7 +29265,7 @@
                   <a:schemeClr val="tx1"/>
                 </a:solidFill>
               </a:rPr>
-              <a:t>A member re-records the tap from globalSeqNo 1; earlier recordings stay on disk, unread.</a:t>
+              <a:t>A member re-records the queue from globalSeqNo 1; earlier recordings stay on disk, unread.</a:t>
             </a:r>
           </a:p>
         </p:txBody>
@@ -29509,7 +29509,7 @@
           <a:lstStyle/>
           <a:p>
             <a:pPr algn="r"/>
-            <a:fld id="{7a49a100-c93f-4df8-aa20-56f79f75f2b6}" type="slidenum">
+            <a:fld id="{7a91b470-ab8b-4d81-83c3-f6ffa72f5213}" type="slidenum">
               <a:rPr lang="en-US" sz="1000" dirty="0">
                 <a:solidFill>
                   <a:schemeClr val="accent5"/>
@@ -30776,7 +30776,7 @@
           <a:lstStyle/>
           <a:p>
             <a:pPr algn="r"/>
-            <a:fld id="{33976db5-5410-41c6-b150-4862a7d1b155}" type="slidenum">
+            <a:fld id="{c5047962-c702-4bc3-a7c9-d383aee634ab}" type="slidenum">
               <a:rPr lang="en-US" sz="1000" dirty="0">
                 <a:solidFill>
                   <a:schemeClr val="accent5"/>
@@ -30915,7 +30915,7 @@
                   <a:schemeClr val="tx1"/>
                 </a:solidFill>
               </a:rPr>
-              <a:t>Clients beside a member, or on a gateway host that relays its tap</a:t>
+              <a:t>Clients beside a member, or on a gateway host that relays its queue</a:t>
             </a:r>
           </a:p>
         </p:txBody>
@@ -31292,7 +31292,7 @@
           <a:lstStyle/>
           <a:p>
             <a:pPr algn="r"/>
-            <a:fld id="{1711738d-28f3-402f-a93f-996350c462cd}" type="slidenum">
+            <a:fld id="{389cb5bf-b6a1-4785-9333-f108179f5e08}" type="slidenum">
               <a:rPr lang="en-US" sz="1000" dirty="0">
                 <a:solidFill>
                   <a:schemeClr val="accent5"/>
@@ -31975,7 +31975,7 @@
           <a:lstStyle/>
           <a:p>
             <a:pPr algn="r"/>
-            <a:fld id="{3bc7b4eb-bb4c-466b-adaa-a375bc31bf8a}" type="slidenum">
+            <a:fld id="{d3057196-3398-49db-a460-018b1b026e25}" type="slidenum">
               <a:rPr lang="en-US" sz="1000" dirty="0">
                 <a:solidFill>
                   <a:schemeClr val="accent5"/>
@@ -32481,7 +32481,7 @@
           <a:lstStyle/>
           <a:p>
             <a:pPr algn="r"/>
-            <a:fld id="{ab087ee5-6231-4b37-a6ac-9b2453368583}" type="slidenum">
+            <a:fld id="{7ba9363e-105e-49a4-99f0-b3dd1ee52f72}" type="slidenum">
               <a:rPr lang="en-US" sz="1000" dirty="0">
                 <a:solidFill>
                   <a:schemeClr val="accent5"/>
@@ -32687,7 +32687,7 @@
                             <a:schemeClr val="tx1"/>
                           </a:solidFill>
                         </a:rPr>
-                        <a:t>Held until the producer's own tap shows it</a:t>
+                        <a:t>Held until the producer's own queue shows it</a:t>
                       </a:r>
                     </a:p>
                   </a:txBody>
@@ -32917,7 +32917,7 @@
                             <a:schemeClr val="tx1"/>
                           </a:solidFill>
                         </a:rPr>
-                        <a:t>Clients, no member; relays a member's tap</a:t>
+                        <a:t>Clients, no member; relays a member's queue</a:t>
                       </a:r>
                     </a:p>
                   </a:txBody>
@@ -33197,7 +33197,7 @@
                             <a:schemeClr val="tx1"/>
                           </a:solidFill>
                         </a:rPr>
-                        <a:t>Recording</a:t>
+                        <a:t>Queue</a:t>
                       </a:r>
                     </a:p>
                   </a:txBody>
@@ -33219,7 +33219,7 @@
                             <a:schemeClr val="tx1"/>
                           </a:solidFill>
                         </a:rPr>
-                        <a:t>The archive's copy of a member's tap</a:t>
+                        <a:t>A member's stream of sequenced frames: IPC 205</a:t>
                       </a:r>
                     </a:p>
                   </a:txBody>
@@ -33243,7 +33243,7 @@
                             <a:schemeClr val="tx1"/>
                           </a:solidFill>
                         </a:rPr>
-                        <a:t>Replayer</a:t>
+                        <a:t>Recording</a:t>
                       </a:r>
                     </a:p>
                   </a:txBody>
@@ -33265,7 +33265,7 @@
                             <a:schemeClr val="tx1"/>
                           </a:solidFill>
                         </a:rPr>
-                        <a:t>Serves history from the recording, per host</a:t>
+                        <a:t>The archive's copy of a member's queue</a:t>
                       </a:r>
                     </a:p>
                   </a:txBody>
@@ -33289,7 +33289,7 @@
                             <a:schemeClr val="tx1"/>
                           </a:solidFill>
                         </a:rPr>
-                        <a:t>Snapshot round</a:t>
+                        <a:t>Replayer</a:t>
                       </a:r>
                     </a:p>
                   </a:txBody>
@@ -33311,7 +33311,7 @@
                             <a:schemeClr val="tx1"/>
                           </a:solidFill>
                         </a:rPr>
-                        <a:t>An application snapshot the log cuts and confirms</a:t>
+                        <a:t>Serves history from the recording, per host</a:t>
                       </a:r>
                     </a:p>
                   </a:txBody>
@@ -33335,7 +33335,7 @@
                             <a:schemeClr val="tx1"/>
                           </a:solidFill>
                         </a:rPr>
-                        <a:t>sourceId</a:t>
+                        <a:t>Snapshot round</a:t>
                       </a:r>
                     </a:p>
                   </a:txBody>
@@ -33357,7 +33357,7 @@
                             <a:schemeClr val="tx1"/>
                           </a:solidFill>
                         </a:rPr>
-                        <a:t>A producer's id: per application or gateway pair</a:t>
+                        <a:t>An application snapshot the log cuts and confirms</a:t>
                       </a:r>
                     </a:p>
                   </a:txBody>
@@ -33381,7 +33381,7 @@
                             <a:schemeClr val="tx1"/>
                           </a:solidFill>
                         </a:rPr>
-                        <a:t>Tap</a:t>
+                        <a:t>sourceId</a:t>
                       </a:r>
                     </a:p>
                   </a:txBody>
@@ -33403,7 +33403,7 @@
                             <a:schemeClr val="tx1"/>
                           </a:solidFill>
                         </a:rPr>
-                        <a:t>A member's stream of sequenced frames: IPC 205</a:t>
+                        <a:t>A producer's id: per application or gateway pair</a:t>
                       </a:r>
                     </a:p>
                   </a:txBody>
@@ -33657,7 +33657,7 @@
           <a:lstStyle/>
           <a:p>
             <a:pPr algn="r"/>
-            <a:fld id="{c34e9706-677a-4072-a69d-bea90f5a7492}" type="slidenum">
+            <a:fld id="{d9212052-f01a-42c6-a38f-dec7f2a4e9d3}" type="slidenum">
               <a:rPr lang="en-US" sz="1000" dirty="0">
                 <a:solidFill>
                   <a:schemeClr val="accent5"/>
@@ -34626,7 +34626,7 @@
           <a:lstStyle/>
           <a:p>
             <a:pPr algn="r"/>
-            <a:fld id="{ba2b0108-6070-48be-8034-4b0e7920e1e8}" type="slidenum">
+            <a:fld id="{48fbed96-6b02-4f76-825e-5ab5a7f34173}" type="slidenum">
               <a:rPr lang="en-US" sz="1000" dirty="0">
                 <a:solidFill>
                   <a:schemeClr val="accent5"/>
@@ -35871,7 +35871,7 @@
           <a:lstStyle/>
           <a:p>
             <a:pPr algn="r"/>
-            <a:fld id="{e04704ac-893a-44f3-ae3b-39648f85920b}" type="slidenum">
+            <a:fld id="{875ba03e-f4d4-436e-8b07-ccd76a31cfa0}" type="slidenum">
               <a:rPr lang="en-US" sz="1000" dirty="0">
                 <a:solidFill>
                   <a:schemeClr val="accent5"/>
@@ -36751,7 +36751,7 @@
           <a:lstStyle/>
           <a:p>
             <a:pPr algn="r"/>
-            <a:fld id="{72aff7d5-fc18-452a-a058-0a1df0d273c7}" type="slidenum">
+            <a:fld id="{21cc3a74-0f67-44c8-8068-196a87a5df16}" type="slidenum">
               <a:rPr lang="en-US" sz="1000" dirty="0">
                 <a:solidFill>
                   <a:schemeClr val="accent5"/>
@@ -36838,7 +36838,7 @@
                   <a:schemeClr val="tx1"/>
                 </a:solidFill>
               </a:rPr>
-              <a:t>Decides when to call the sequencer; its tap is the frame sink. Holds no replicated state.</a:t>
+              <a:t>Decides when to call the sequencer; its queue is the frame sink. Holds no replicated state.</a:t>
             </a:r>
           </a:p>
         </p:txBody>
@@ -37046,7 +37046,7 @@
                 </a:solidFill>
                 <a:latin typeface="+mj-lt"/>
               </a:rPr>
-              <a:t>TapPublisher</a:t>
+              <a:t>QueuePublisher</a:t>
             </a:r>
           </a:p>
           <a:p>
@@ -37072,7 +37072,7 @@
                   <a:schemeClr val="tx1"/>
                 </a:solidFill>
               </a:rPr>
-              <a:t>Retries the tap offer; watches RecordingPos; terminates the member on a stalled archive.</a:t>
+              <a:t>Retries the queue offer; watches RecordingPos; terminates the member on a stalled archive.</a:t>
             </a:r>
           </a:p>
         </p:txBody>
@@ -37246,7 +37246,7 @@
           <a:lstStyle/>
           <a:p>
             <a:pPr algn="r"/>
-            <a:fld id="{17425e13-dbc3-4dc4-bb48-873c38ee1a2a}" type="slidenum">
+            <a:fld id="{27f10b4a-5787-48a3-80bc-3e50ec260927}" type="slidenum">
               <a:rPr lang="en-US" sz="1000" dirty="0">
                 <a:solidFill>
                   <a:schemeClr val="accent5"/>
@@ -38154,7 +38154,7 @@
           <a:lstStyle/>
           <a:p>
             <a:pPr algn="r"/>
-            <a:fld id="{1ff65065-3744-4e37-9167-2425348b92f7}" type="slidenum">
+            <a:fld id="{6be8c147-02a7-45a3-a5d3-570c7b9c9073}" type="slidenum">
               <a:rPr lang="en-US" sz="1000" dirty="0">
                 <a:solidFill>
                   <a:schemeClr val="accent5"/>
@@ -38659,7 +38659,7 @@
           <a:lstStyle/>
           <a:p>
             <a:pPr algn="r"/>
-            <a:fld id="{3f98d41c-ec63-452e-bb7d-57176d16cd0e}" type="slidenum">
+            <a:fld id="{18408195-ac31-4a59-9274-ced3b26b0e53}" type="slidenum">
               <a:rPr lang="en-US" sz="1000" dirty="0">
                 <a:solidFill>
                   <a:schemeClr val="accent5"/>
@@ -39206,7 +39206,7 @@
                   <a:schemeClr val="accent5"/>
                 </a:solidFill>
               </a:rPr>
-              <a:t>Walk the recording to its end, then follow the tap</a:t>
+              <a:t>Walk the recording to its end, then follow the queue</a:t>
             </a:r>
           </a:p>
         </p:txBody>
@@ -39232,7 +39232,7 @@
           <a:lstStyle/>
           <a:p>
             <a:pPr algn="r"/>
-            <a:fld id="{376a3405-c88a-471a-a06a-37196f2e9055}" type="slidenum">
+            <a:fld id="{15b0e92d-fc0d-46f4-b47e-5ddc3c931cba}" type="slidenum">
               <a:rPr lang="en-US" sz="1000" dirty="0">
                 <a:solidFill>
                   <a:schemeClr val="accent5"/>
@@ -39292,7 +39292,7 @@
                   <a:schemeClr val="tx1"/>
                 </a:solidFill>
               </a:rPr>
-              <a:t>Live tap</a:t>
+              <a:t>Live queue</a:t>
             </a:r>
           </a:p>
           <a:p>
@@ -39498,7 +39498,7 @@
                   <a:schemeClr val="accent5"/>
                 </a:solidFill>
               </a:rPr>
-              <a:t>active tap recording</a:t>
+              <a:t>active queue recording</a:t>
             </a:r>
           </a:p>
         </p:txBody>
@@ -39708,7 +39708,7 @@
                   <a:schemeClr val="accent5"/>
                 </a:solidFill>
               </a:rPr>
-              <a:t>live tap</a:t>
+              <a:t>live queue</a:t>
             </a:r>
           </a:p>
         </p:txBody>
@@ -40749,7 +40749,7 @@
                   <a:schemeClr val="tx1"/>
                 </a:solidFill>
               </a:rPr>
-              <a:t>publication gone → slot freed for the queue</a:t>
+              <a:t>publication gone → slot freed for the next request</a:t>
             </a:r>
           </a:p>
         </p:txBody>
@@ -40935,7 +40935,7 @@
           <a:lstStyle/>
           <a:p>
             <a:pPr algn="r"/>
-            <a:fld id="{2c6a9f33-8b66-4fa1-8081-4ed4dd4029d0}" type="slidenum">
+            <a:fld id="{5ebf1210-6e5f-4283-8742-d2596202b71d}" type="slidenum">
               <a:rPr lang="en-US" sz="1000" dirty="0">
                 <a:solidFill>
                   <a:schemeClr val="accent5"/>
@@ -40995,7 +40995,7 @@
                   <a:schemeClr val="tx1"/>
                 </a:solidFill>
               </a:rPr>
-              <a:t>Live tap</a:t>
+              <a:t>Live queue</a:t>
             </a:r>
           </a:p>
           <a:p>
@@ -41201,7 +41201,7 @@
                   <a:schemeClr val="accent5"/>
                 </a:solidFill>
               </a:rPr>
-              <a:t>active tap recording</a:t>
+              <a:t>active queue recording</a:t>
             </a:r>
           </a:p>
         </p:txBody>
@@ -41411,7 +41411,7 @@
                   <a:schemeClr val="accent5"/>
                 </a:solidFill>
               </a:rPr>
-              <a:t>live tap</a:t>
+              <a:t>live queue</a:t>
             </a:r>
           </a:p>
         </p:txBody>
@@ -42979,7 +42979,7 @@
           <a:lstStyle/>
           <a:p>
             <a:pPr algn="r"/>
-            <a:fld id="{6807e5b4-5cdd-4d29-b278-3b7c6b75dc74}" type="slidenum">
+            <a:fld id="{f4704458-edd9-4b41-ba64-0dc6b39e11d4}" type="slidenum">
               <a:rPr lang="en-US" sz="1000" dirty="0">
                 <a:solidFill>
                   <a:schemeClr val="accent5"/>
@@ -43757,7 +43757,7 @@
                   <a:schemeClr val="tx1"/>
                 </a:solidFill>
               </a:rPr>
-              <a:t>Closes its edge, keeps its session, keeps following the tap. Nothing it sends is sequenced. Can be designated again.</a:t>
+              <a:t>Closes its edge, keeps its session, keeps following the queue. Nothing it sends is sequenced. Can be designated again.</a:t>
             </a:r>
           </a:p>
         </p:txBody>
@@ -43907,7 +43907,7 @@
                   <a:schemeClr val="accent5"/>
                 </a:solidFill>
               </a:rPr>
-              <a:t>Each application follows its own member's tap; only the leader's publishes</a:t>
+              <a:t>Each application follows its own member's queue; only the leader's publishes</a:t>
             </a:r>
           </a:p>
         </p:txBody>
@@ -43933,7 +43933,7 @@
           <a:lstStyle/>
           <a:p>
             <a:pPr algn="r"/>
-            <a:fld id="{4978b646-5561-4f24-a7c5-8b17eca2a178}" type="slidenum">
+            <a:fld id="{c5949be6-3e85-437a-9440-3496bb727d0d}" type="slidenum">
               <a:rPr lang="en-US" sz="1000" dirty="0">
                 <a:solidFill>
                   <a:schemeClr val="accent5"/>
@@ -44890,7 +44890,7 @@
                   <a:schemeClr val="accent5"/>
                 </a:solidFill>
               </a:rPr>
-              <a:t>local · TapRelay: the host's own tap</a:t>
+              <a:t>local · QueueRelay: the host's own queue</a:t>
             </a:r>
           </a:p>
         </p:txBody>
@@ -45104,7 +45104,7 @@
                   <a:schemeClr val="accent5"/>
                 </a:solidFill>
               </a:rPr>
-              <a:t>Teal: the tap, live.</a:t>
+              <a:t>Teal: the queue, live.</a:t>
             </a:r>
           </a:p>
           <a:p>
@@ -45180,7 +45180,7 @@
                   <a:schemeClr val="tx1"/>
                 </a:solidFill>
               </a:rPr>
-              <a:t>Every application follows its own member's tap and holds the same state</a:t>
+              <a:t>Every application follows its own member's queue and holds the same state</a:t>
             </a:r>
           </a:p>
           <a:p>
@@ -45261,7 +45261,7 @@
                 </a:solidFill>
                 <a:latin typeface="+mj-lt"/>
               </a:rPr>
-              <a:t>Remote hosts: the tap relay</a:t>
+              <a:t>Remote hosts: the queue relay</a:t>
             </a:r>
           </a:p>
         </p:txBody>
@@ -45321,7 +45321,7 @@
           <a:lstStyle/>
           <a:p>
             <a:pPr algn="r"/>
-            <a:fld id="{bf475e62-6f48-4eea-812f-760b091947ae}" type="slidenum">
+            <a:fld id="{058578f6-badf-4d04-bb78-bc7be20ce43f}" type="slidenum">
               <a:rPr lang="en-US" sz="1000" dirty="0">
                 <a:solidFill>
                   <a:schemeClr val="accent5"/>
@@ -45782,7 +45782,7 @@
                   <a:schemeClr val="tx1"/>
                 </a:solidFill>
               </a:rPr>
-              <a:t>TapRelay</a:t>
+              <a:t>QueueRelay</a:t>
             </a:r>
           </a:p>
           <a:p>
@@ -45807,7 +45807,7 @@
         <p:spPr>
           <a:xfrm>
             <a:off x="4526280" y="3044952"/>
-            <a:ext cx="1280160" cy="219456"/>
+            <a:ext cx="1737360" cy="219456"/>
           </a:xfrm>
           <a:prstGeom prst="rect">
             <a:avLst/>
@@ -45827,14 +45827,14 @@
                   <a:schemeClr val="accent1"/>
                 </a:solidFill>
               </a:rPr>
-              <a:t>Tap · aeron:ipc 205</a:t>
-            </a:r>
-          </a:p>
-        </p:txBody>
-      </p:sp>
-      <p:sp>
-        <p:nvSpPr>
-          <p:cNvPr id="9055" name="Tap cell 724"/>
+              <a:t>Queue · aeron:ipc 205</a:t>
+            </a:r>
+          </a:p>
+        </p:txBody>
+      </p:sp>
+      <p:sp>
+        <p:nvSpPr>
+          <p:cNvPr id="9055" name="Queue cell 724"/>
           <p:cNvSpPr/>
           <p:nvPr/>
         </p:nvSpPr>
@@ -45888,7 +45888,7 @@
       </p:sp>
       <p:sp>
         <p:nvSpPr>
-          <p:cNvPr id="9056" name="Tap cell 725"/>
+          <p:cNvPr id="9056" name="Queue cell 725"/>
           <p:cNvSpPr/>
           <p:nvPr/>
         </p:nvSpPr>
@@ -45942,7 +45942,7 @@
       </p:sp>
       <p:sp>
         <p:nvSpPr>
-          <p:cNvPr id="9057" name="Tap cell 726"/>
+          <p:cNvPr id="9057" name="Queue cell 726"/>
           <p:cNvSpPr/>
           <p:nvPr/>
         </p:nvSpPr>
@@ -45996,7 +45996,7 @@
       </p:sp>
       <p:sp>
         <p:nvSpPr>
-          <p:cNvPr id="9058" name="Tap cell 727"/>
+          <p:cNvPr id="9058" name="Queue cell 727"/>
           <p:cNvSpPr/>
           <p:nvPr/>
         </p:nvSpPr>
@@ -46050,7 +46050,7 @@
       </p:sp>
       <p:sp>
         <p:nvSpPr>
-          <p:cNvPr id="9059" name="Tap cell 728"/>
+          <p:cNvPr id="9059" name="Queue cell 728"/>
           <p:cNvSpPr/>
           <p:nvPr/>
         </p:nvSpPr>
@@ -46102,7 +46102,7 @@
       </p:sp>
       <p:sp>
         <p:nvSpPr>
-          <p:cNvPr id="9060" name="Tap cell 729"/>
+          <p:cNvPr id="9060" name="Queue cell 729"/>
           <p:cNvSpPr/>
           <p:nvPr/>
         </p:nvSpPr>
@@ -46148,7 +46148,7 @@
       </p:sp>
       <p:sp>
         <p:nvSpPr>
-          <p:cNvPr id="9061" name="Tap cell 730"/>
+          <p:cNvPr id="9061" name="Queue cell 730"/>
           <p:cNvSpPr/>
           <p:nvPr/>
         </p:nvSpPr>
@@ -46252,7 +46252,7 @@
                   <a:schemeClr val="accent5"/>
                 </a:solidFill>
               </a:rPr>
-              <a:t>records the tap</a:t>
+              <a:t>records the queue</a:t>
             </a:r>
           </a:p>
         </p:txBody>
@@ -46627,7 +46627,7 @@
           <a:lstStyle/>
           <a:p>
             <a:pPr algn="r"/>
-            <a:fld id="{51e94e0f-d968-406d-bd07-b6d52e94f867}" type="slidenum">
+            <a:fld id="{d93f7dfb-a866-4c8c-b66b-75e6daaaea65}" type="slidenum">
               <a:rPr lang="en-US" sz="1000" dirty="0">
                 <a:solidFill>
                   <a:schemeClr val="accent5"/>
@@ -46771,7 +46771,7 @@
                   <a:schemeClr val="tx1"/>
                 </a:solidFill>
               </a:rPr>
-              <a:t>A gateway instance that announced itself on the lost session. Closing that session promotes its sibling, and the tap carries no frame for the close.</a:t>
+              <a:t>A gateway instance that announced itself on the lost session. Closing that session promotes its sibling, and the queue carries no frame for the close.</a:t>
             </a:r>
           </a:p>
         </p:txBody>
@@ -46839,7 +46839,7 @@
                   <a:schemeClr val="tx1"/>
                 </a:solidFill>
               </a:rPr>
-              <a:t>What was unconfirmed on the old session is not resent: its close is on no tap, so what reached the log cannot be counted.</a:t>
+              <a:t>What was unconfirmed on the old session is not resent: its close is on no queue, so what reached the log cannot be counted.</a:t>
             </a:r>
           </a:p>
         </p:txBody>
@@ -47005,7 +47005,7 @@
           <a:lstStyle/>
           <a:p>
             <a:pPr algn="r"/>
-            <a:fld id="{606ea4bf-8d53-414d-a7aa-d27603dc756f}" type="slidenum">
+            <a:fld id="{b6a2003c-27c4-43e9-8364-bdf5706d7d07}" type="slidenum">
               <a:rPr lang="en-US" sz="1000" dirty="0">
                 <a:solidFill>
                   <a:schemeClr val="accent5"/>
@@ -47719,7 +47719,7 @@
           <a:lstStyle/>
           <a:p>
             <a:pPr algn="r"/>
-            <a:fld id="{6991ff2d-c6d6-4606-a05c-d833aac5d40e}" type="slidenum">
+            <a:fld id="{baf84e9f-9383-468a-970e-7c2e3d876b74}" type="slidenum">
               <a:rPr lang="en-US" sz="1000" dirty="0">
                 <a:solidFill>
                   <a:schemeClr val="accent5"/>
@@ -47779,7 +47779,7 @@
                   <a:schemeClr val="tx1"/>
                 </a:solidFill>
               </a:rPr>
-              <a:t>Live tap</a:t>
+              <a:t>Live queue</a:t>
             </a:r>
           </a:p>
           <a:p>
@@ -47985,7 +47985,7 @@
                   <a:schemeClr val="accent5"/>
                 </a:solidFill>
               </a:rPr>
-              <a:t>active tap recording</a:t>
+              <a:t>active queue recording</a:t>
             </a:r>
           </a:p>
         </p:txBody>
@@ -48195,7 +48195,7 @@
                   <a:schemeClr val="accent5"/>
                 </a:solidFill>
               </a:rPr>
-              <a:t>live tap</a:t>
+              <a:t>live queue</a:t>
             </a:r>
           </a:p>
         </p:txBody>
@@ -49618,7 +49618,7 @@
           <a:lstStyle/>
           <a:p>
             <a:pPr algn="r"/>
-            <a:fld id="{d986deb6-cda5-4b21-86b6-e0159eab5db5}" type="slidenum">
+            <a:fld id="{5d769e2c-49cc-4142-a6c8-10d61492d9e3}" type="slidenum">
               <a:rPr lang="en-US" sz="1000" dirty="0">
                 <a:solidFill>
                   <a:schemeClr val="accent5"/>
@@ -49882,7 +49882,7 @@
                   <a:schemeClr val="accent5"/>
                 </a:solidFill>
               </a:rPr>
-              <a:t>active tap recording</a:t>
+              <a:t>active queue recording</a:t>
             </a:r>
           </a:p>
         </p:txBody>
@@ -50092,7 +50092,7 @@
                   <a:schemeClr val="accent5"/>
                 </a:solidFill>
               </a:rPr>
-              <a:t>live tap</a:t>
+              <a:t>live queue</a:t>
             </a:r>
           </a:p>
         </p:txBody>
@@ -51452,7 +51452,7 @@
           <a:lstStyle/>
           <a:p>
             <a:pPr algn="r"/>
-            <a:fld id="{0cb1a3fa-0ebb-41cb-8983-47f717ca4841}" type="slidenum">
+            <a:fld id="{78dabe81-0bb8-4366-939d-4816477eb5e7}" type="slidenum">
               <a:rPr lang="en-US" sz="1000" dirty="0">
                 <a:solidFill>
                   <a:schemeClr val="accent5"/>
@@ -51928,7 +51928,7 @@
                   <a:schemeClr val="accent5"/>
                 </a:solidFill>
               </a:rPr>
-              <a:t>tap</a:t>
+              <a:t>queue</a:t>
             </a:r>
           </a:p>
         </p:txBody>
@@ -52180,7 +52180,7 @@
                   <a:schemeClr val="tx1"/>
                 </a:solidFill>
               </a:rPr>
-              <a:t>SnapshotStarted(r) on every tap: the cut R</a:t>
+              <a:t>SnapshotStarted(r) on every queue: the cut R</a:t>
             </a:r>
           </a:p>
         </p:txBody>
@@ -52398,7 +52398,7 @@
                   <a:schemeClr val="tx1"/>
                 </a:solidFill>
               </a:rPr>
-              <a:t>SnapshotEnd sequenced, on every tap</a:t>
+              <a:t>SnapshotEnd sequenced, on every queue</a:t>
             </a:r>
           </a:p>
         </p:txBody>
@@ -53119,7 +53119,7 @@
           <a:lstStyle/>
           <a:p>
             <a:pPr algn="r"/>
-            <a:fld id="{07725152-1467-4c02-a432-099ee5d20574}" type="slidenum">
+            <a:fld id="{a535fc2a-d467-4666-bd0b-e637f94450a9}" type="slidenum">
               <a:rPr lang="en-US" sz="1000" dirty="0">
                 <a:solidFill>
                   <a:schemeClr val="accent5"/>
@@ -54514,7 +54514,7 @@
           <a:lstStyle/>
           <a:p>
             <a:pPr algn="r"/>
-            <a:fld id="{c3457510-3fe7-4e41-ade2-52bc18e2a3d5}" type="slidenum">
+            <a:fld id="{4a24f5de-e44f-487f-b18b-01188e0421b9}" type="slidenum">
               <a:rPr lang="en-US" sz="1000" dirty="0">
                 <a:solidFill>
                   <a:schemeClr val="accent5"/>
@@ -55344,7 +55344,7 @@
           <a:lstStyle/>
           <a:p>
             <a:pPr algn="r"/>
-            <a:fld id="{d0b28cc7-36b4-44cc-89e5-04c02370ae8e}" type="slidenum">
+            <a:fld id="{beae07c2-856c-4a9b-bd55-bbd862782fe2}" type="slidenum">
               <a:rPr lang="en-US" sz="1000" dirty="0">
                 <a:solidFill>
                   <a:schemeClr val="accent5"/>
@@ -55707,7 +55707,7 @@
                             <a:schemeClr val="tx1"/>
                           </a:solidFill>
                         </a:rPr>
-                        <a:t>onClusterHeartbeat, on consensus time; resets the tap-stall fence</a:t>
+                        <a:t>onClusterHeartbeat, on consensus time; resets the queue-stall fence</a:t>
                       </a:r>
                     </a:p>
                   </a:txBody>
@@ -56061,7 +56061,7 @@
           <a:lstStyle/>
           <a:p>
             <a:pPr algn="r"/>
-            <a:fld id="{86b3b15d-e252-4652-a5d9-f37987c1d733}" type="slidenum">
+            <a:fld id="{2eefc841-b5da-4204-8797-c043e926df55}" type="slidenum">
               <a:rPr lang="en-US" sz="1000" dirty="0">
                 <a:solidFill>
                   <a:schemeClr val="accent5"/>
@@ -56199,7 +56199,7 @@
                             <a:schemeClr val="tx1"/>
                           </a:solidFill>
                         </a:rPr>
-                        <a:t>TAP_STALLED</a:t>
+                        <a:t>QUEUE_STALLED</a:t>
                       </a:r>
                     </a:p>
                   </a:txBody>
@@ -56313,7 +56313,7 @@
                             <a:schemeClr val="tx1"/>
                           </a:solidFill>
                         </a:rPr>
-                        <a:t>An own frame on the tap differs from the oldest pending one</a:t>
+                        <a:t>An own frame on the queue differs from the oldest pending one</a:t>
                       </a:r>
                     </a:p>
                   </a:txBody>
@@ -56597,7 +56597,7 @@
           <a:lstStyle/>
           <a:p>
             <a:pPr algn="r"/>
-            <a:fld id="{8ab6cb6c-8ca4-4354-b78e-80a4d547ba5c}" type="slidenum">
+            <a:fld id="{6c1bcc72-9f17-4d25-983b-bb08fe539ee9}" type="slidenum">
               <a:rPr lang="en-US" sz="1000" dirty="0">
                 <a:solidFill>
                   <a:schemeClr val="accent5"/>
@@ -57756,7 +57756,7 @@
           <a:lstStyle/>
           <a:p>
             <a:pPr algn="r"/>
-            <a:fld id="{37da00d2-1aee-4b3e-9b01-825fdea367e2}" type="slidenum">
+            <a:fld id="{dfcac94b-478d-4c82-be36-1a5c24752895}" type="slidenum">
               <a:rPr lang="en-US" sz="1000" dirty="0">
                 <a:solidFill>
                   <a:schemeClr val="accent5"/>
@@ -58029,7 +58029,7 @@
                   <a:schemeClr val="tx1"/>
                 </a:solidFill>
               </a:rPr>
-              <a:t>A reliable tap that is still bounded; untethered consumers that cannot slow the sequencer.</a:t>
+              <a:t>A reliable queue that is still bounded; untethered consumers that cannot slow the sequencer.</a:t>
             </a:r>
           </a:p>
         </p:txBody>
@@ -58711,7 +58711,7 @@
           <a:lstStyle/>
           <a:p>
             <a:pPr algn="r"/>
-            <a:fld id="{f23e7ccb-8463-4a67-ac0f-e38fde2a9314}" type="slidenum">
+            <a:fld id="{89ac4db8-737e-4b35-918d-10ea7bc77049}" type="slidenum">
               <a:rPr lang="en-US" sz="1000" dirty="0">
                 <a:solidFill>
                   <a:schemeClr val="accent5"/>
@@ -58870,7 +58870,7 @@
                             <a:schemeClr val="tx1"/>
                           </a:solidFill>
                         </a:rPr>
-                        <a:t>Confirmed ingress: held until its own tap shows it, resent after a term change</a:t>
+                        <a:t>Confirmed ingress: held until its own queue shows it, resent after a term change</a:t>
                       </a:r>
                     </a:p>
                   </a:txBody>
@@ -59006,7 +59006,7 @@
                             <a:schemeClr val="tx1"/>
                           </a:solidFill>
                         </a:rPr>
-                        <a:t>ClusterHeartbeat: 1 Hz on consensus time, on every tap</a:t>
+                        <a:t>ClusterHeartbeat: 1 Hz on consensus time, on every queue</a:t>
                       </a:r>
                     </a:p>
                   </a:txBody>
@@ -59430,7 +59430,7 @@
           <a:lstStyle/>
           <a:p>
             <a:pPr algn="r"/>
-            <a:fld id="{5a853780-350f-4199-a179-567ee8682e5c}" type="slidenum">
+            <a:fld id="{7ca46945-e52e-4d8c-a9ad-cd6117050ae0}" type="slidenum">
               <a:rPr lang="en-US" sz="1000" dirty="0">
                 <a:solidFill>
                   <a:schemeClr val="accent5"/>
@@ -59524,7 +59524,7 @@
                   <a:schemeClr val="accent5"/>
                 </a:solidFill>
               </a:rPr>
-              <a:t>same pipeline, byte-identical tap</a:t>
+              <a:t>same pipeline, byte-identical queue</a:t>
             </a:r>
           </a:p>
         </p:txBody>
@@ -59859,7 +59859,7 @@
         <p:spPr>
           <a:xfrm>
             <a:off x="3368234" y="2877243"/>
-            <a:ext cx="1309255" cy="240030"/>
+            <a:ext cx="1854777" cy="240030"/>
           </a:xfrm>
           <a:prstGeom prst="rect">
             <a:avLst/>
@@ -59879,14 +59879,14 @@
                   <a:schemeClr val="accent1"/>
                 </a:solidFill>
               </a:rPr>
-              <a:t>Tap · aeron:ipc 205</a:t>
-            </a:r>
-          </a:p>
-        </p:txBody>
-      </p:sp>
-      <p:sp>
-        <p:nvSpPr>
-          <p:cNvPr id="9017" name="Tap cell 110"/>
+              <a:t>Queue · aeron:ipc 205</a:t>
+            </a:r>
+          </a:p>
+        </p:txBody>
+      </p:sp>
+      <p:sp>
+        <p:nvSpPr>
+          <p:cNvPr id="9017" name="Queue cell 110"/>
           <p:cNvSpPr/>
           <p:nvPr/>
         </p:nvSpPr>
@@ -59940,7 +59940,7 @@
       </p:sp>
       <p:sp>
         <p:nvSpPr>
-          <p:cNvPr id="9018" name="Tap cell 111"/>
+          <p:cNvPr id="9018" name="Queue cell 111"/>
           <p:cNvSpPr/>
           <p:nvPr/>
         </p:nvSpPr>
@@ -59994,7 +59994,7 @@
       </p:sp>
       <p:sp>
         <p:nvSpPr>
-          <p:cNvPr id="9019" name="Tap cell 112"/>
+          <p:cNvPr id="9019" name="Queue cell 112"/>
           <p:cNvSpPr/>
           <p:nvPr/>
         </p:nvSpPr>
@@ -60048,7 +60048,7 @@
       </p:sp>
       <p:sp>
         <p:nvSpPr>
-          <p:cNvPr id="9020" name="Tap cell 113"/>
+          <p:cNvPr id="9020" name="Queue cell 113"/>
           <p:cNvSpPr/>
           <p:nvPr/>
         </p:nvSpPr>
@@ -60102,7 +60102,7 @@
       </p:sp>
       <p:sp>
         <p:nvSpPr>
-          <p:cNvPr id="9021" name="Tap cell 114"/>
+          <p:cNvPr id="9021" name="Queue cell 114"/>
           <p:cNvSpPr/>
           <p:nvPr/>
         </p:nvSpPr>
@@ -60154,7 +60154,7 @@
       </p:sp>
       <p:sp>
         <p:nvSpPr>
-          <p:cNvPr id="9022" name="Tap cell 115"/>
+          <p:cNvPr id="9022" name="Queue cell 115"/>
           <p:cNvSpPr/>
           <p:nvPr/>
         </p:nvSpPr>
@@ -60200,7 +60200,7 @@
       </p:sp>
       <p:sp>
         <p:nvSpPr>
-          <p:cNvPr id="9023" name="Tap cell 116"/>
+          <p:cNvPr id="9023" name="Queue cell 116"/>
           <p:cNvSpPr/>
           <p:nvPr/>
         </p:nvSpPr>
@@ -60340,7 +60340,7 @@
                   <a:schemeClr val="accent5"/>
                 </a:solidFill>
               </a:rPr>
-              <a:t>records the tap · tethered</a:t>
+              <a:t>records the queue · tethered</a:t>
             </a:r>
           </a:p>
         </p:txBody>
@@ -60543,7 +60543,7 @@
                   <a:schemeClr val="accent5"/>
                 </a:solidFill>
               </a:rPr>
-              <a:t>tap 205 · replay 201 · request 202 · control 203</a:t>
+              <a:t>queue 205 · replay 201 · request 202 · control 203</a:t>
             </a:r>
           </a:p>
         </p:txBody>
@@ -61137,7 +61137,7 @@
           <a:lstStyle/>
           <a:p>
             <a:pPr algn="r"/>
-            <a:fld id="{11fda368-c3ab-4535-ae9d-1fcd9c01f411}" type="slidenum">
+            <a:fld id="{5dff6ea5-a947-4c5f-9593-1958c6c800f1}" type="slidenum">
               <a:rPr lang="en-US" sz="1000" dirty="0">
                 <a:solidFill>
                   <a:schemeClr val="accent5"/>
@@ -61541,7 +61541,7 @@
                   <a:schemeClr val="tx1"/>
                 </a:solidFill>
               </a:rPr>
-              <a:t>Every cluster member numbers, stamps, publishes on its tap.</a:t>
+              <a:t>Every cluster member numbers, stamps, publishes on its queue.</a:t>
             </a:r>
           </a:p>
         </p:txBody>
@@ -61662,7 +61662,7 @@
                   <a:schemeClr val="tx1"/>
                 </a:solidFill>
               </a:rPr>
-              <a:t>Every cluster member's archive records the tap.</a:t>
+              <a:t>Every cluster member's archive records the queue.</a:t>
             </a:r>
           </a:p>
         </p:txBody>
@@ -61783,7 +61783,7 @@
                   <a:schemeClr val="tx1"/>
                 </a:solidFill>
               </a:rPr>
-              <a:t>Each client reads its local tap, checks continuity.</a:t>
+              <a:t>Each client reads its local queue, checks continuity.</a:t>
             </a:r>
           </a:p>
         </p:txBody>
@@ -61964,7 +61964,7 @@
                   <a:schemeClr val="tx1"/>
                 </a:solidFill>
               </a:rPr>
-              <a:t>The cluster confirms nothing on egress; step 6 is the producer's own confirmation, on its own tap.</a:t>
+              <a:t>The cluster confirms nothing on egress; step 6 is the producer's own confirmation, on its own queue.</a:t>
             </a:r>
           </a:p>
         </p:txBody>

</xml_diff>